<commit_message>
Re-render the four talk artifacts
Co-authored-by: Eli Pedro <elipcs@users.noreply.github.com>
</commit_message>
<xml_diff>
--- a/docs/presentation/slides.pptx
+++ b/docs/presentation/slides.pptx
@@ -524,25 +524,25 @@
           <a:p/>
           <a:p>
             <a:r>
-              <a:t>Good morning. Our paper is called Grading Is Easy, Feedback Is Hard, and the artifact I want to show you is the machinery behind that title.</a:t>
+              <a:t>Good morning. Our paper is called Grading Is Easy, Feedback Is Hard, and what I am presenting today is the artifact behind it.</a:t>
             </a:r>
           </a:p>
           <a:p/>
           <a:p>
             <a:r>
-              <a:t>It is a replication package for evaluating large language models as instructor-support tools on a design-oriented object-oriented programming assignment. Eighty-four real Java submissions, two models, a complete prompt protocol, and every intermediate file.</a:t>
+              <a:t>It is a replication package: eighty-four real Java submissions from an object-oriented programming course, two models, a complete prompt protocol, and every intermediate file we produced, down to the exact bytes we sent to each provider.</a:t>
             </a:r>
           </a:p>
           <a:p/>
           <a:p>
             <a:r>
-              <a:t>Everything I show runs on your laptop without an API key.</a:t>
+              <a:t>Everything I show runs on your laptop, without an API key, in one command.</a:t>
             </a:r>
           </a:p>
           <a:p/>
           <a:p>
             <a:r>
-              <a:t>(70 words / 30s window, budget 72)</a:t>
+              <a:t>(73 words / 30s window, budget 72)</a:t>
             </a:r>
           </a:p>
         </p:txBody>
@@ -800,43 +800,55 @@
           <a:lstStyle/>
           <a:p>
             <a:r>
-              <a:t>[00:30 - 01:15]  slide 02 of 11</a:t>
+              <a:t>[00:30 - 01:20]  slide 02 of 11</a:t>
             </a:r>
           </a:p>
           <a:p/>
           <a:p>
             <a:r>
-              <a:t>First, why we needed an artifact at all.</a:t>
+              <a:t>CUE: This is the only paper slide. Do not drift into results.</a:t>
             </a:r>
           </a:p>
           <a:p/>
           <a:p>
             <a:r>
-              <a:t>In our OOP course students refactor a deliberately weak codebase, so correctness and design pull apart. Submission A can pass every feature check while being one four-hundred-line class with no domain objects. Submission B can have a single off-by-one bug on top of a clean class model.</a:t>
+              <a:t>One slide on the paper this comes from, and then we stay on the artifact.</a:t>
             </a:r>
           </a:p>
           <a:p/>
           <a:p>
             <a:r>
-              <a:t>Unit tests and static analysis rank A above B. An instructor does not.</a:t>
+              <a:t>The paper is an evaluation protocol for using language models to assess design-oriented object-oriented programming assignments. This artifact is that protocol, made runnable.</a:t>
             </a:r>
           </a:p>
           <a:p/>
           <a:p>
             <a:r>
-              <a:t>So this assessment stays manual: eighty-four submissions, seven rubric criteria each, plus written feedback, across twenty-eight teaching assistants.</a:t>
+              <a:t>Its central claim is that one aggregate score merges two capabilities that behave differently. Grade concordance asks whether the score matches the human baseline. Diagnostic alignment asks whether the model names the same problems an expert found.</a:t>
             </a:r>
           </a:p>
           <a:p/>
           <a:p>
             <a:r>
-              <a:t>The obvious question is whether an LLM can help. The harder one is how you would measure "help" at all.</a:t>
+              <a:t>We measure them separately, against human references, on the same submissions, under one fixed prompt protocol, so that the two can never be blurred into a single number.</a:t>
             </a:r>
           </a:p>
           <a:p/>
           <a:p>
             <a:r>
-              <a:t>(106 words / 45s window, budget 109)</a:t>
+              <a:t>The title gives away what we found. I am here for the machinery behind that sentence, not for the numbers.</a:t>
+            </a:r>
+          </a:p>
+          <a:p/>
+          <a:p>
+            <a:r>
+              <a:t>IF AHEAD: Both dimensions are measured per submission and per rubric criterion, never as a single headline score.</a:t>
+            </a:r>
+          </a:p>
+          <a:p/>
+          <a:p>
+            <a:r>
+              <a:t>(123 words / 50s window, budget 121)</a:t>
             </a:r>
           </a:p>
         </p:txBody>
@@ -906,31 +918,43 @@
           <a:lstStyle/>
           <a:p>
             <a:r>
-              <a:t>[01:15 - 01:50]  slide 03 of 11</a:t>
+              <a:t>[01:20 - 02:05]  slide 03 of 11</a:t>
             </a:r>
           </a:p>
           <a:p/>
           <a:p>
             <a:r>
-              <a:t>Here is what you get.</a:t>
+              <a:t>First, why we needed an artifact at all.</a:t>
             </a:r>
           </a:p>
           <a:p/>
           <a:p>
             <a:r>
-              <a:t>src/prompt is the grading protocol - eight files, and I would argue that is the real contribution. src/pipeline and src/workflows are twenty-three scripts: render prompts, call providers, validate outputs, compute statistics. And reproduce.py rebuilds the entire paper in one command.</a:t>
+              <a:t>In our OOP course students refactor a deliberately weak codebase, so correctness and design pull apart. Submission A can pass every feature check while being one four-hundred-line class with no domain objects. Submission B can have a single off-by-one bug on top of a clean class model.</a:t>
             </a:r>
           </a:p>
           <a:p/>
           <a:p>
             <a:r>
-              <a:t>Then the data: six run directories, two models times three repetitions. Each holds the anonymized submissions, the rubric, one thousand and eight rendered prompts - the exact bytes we sent - five hundred and four model assessments, the TA grades and the expert reference.</a:t>
+              <a:t>Unit tests and static analysis rank A above B. An instructor does not.</a:t>
             </a:r>
           </a:p>
           <a:p/>
           <a:p>
             <a:r>
-              <a:t>(89 words / 35s window, budget 85)</a:t>
+              <a:t>So this assessment stays manual: eighty-four submissions, seven rubric criteria each, plus written feedback, across twenty-eight teaching assistants.</a:t>
+            </a:r>
+          </a:p>
+          <a:p/>
+          <a:p>
+            <a:r>
+              <a:t>The obvious question is whether an LLM can help. The harder one is how you would measure "help" at all.</a:t>
+            </a:r>
+          </a:p>
+          <a:p/>
+          <a:p>
+            <a:r>
+              <a:t>(106 words / 45s window, budget 109)</a:t>
             </a:r>
           </a:p>
         </p:txBody>
@@ -1000,37 +1024,31 @@
           <a:lstStyle/>
           <a:p>
             <a:r>
-              <a:t>[01:50 - 02:55]  slide 04 of 11</a:t>
+              <a:t>[02:05 - 02:40]  slide 04 of 11</a:t>
             </a:r>
           </a:p>
           <a:p/>
           <a:p>
             <a:r>
-              <a:t>Now the prompt, because that is what people usually want to see. We split grading into two calls, deliberately.</a:t>
+              <a:t>Here is what you get.</a:t>
             </a:r>
           </a:p>
           <a:p/>
           <a:p>
             <a:r>
-              <a:t>Stage one is scoring only - the prompt forbids student-facing prose here. For every rubric criterion the model must return a score, positive evidence of learning, observations that should not cost points, and a list of deductions. Every deduction is structured: points lost, severity, confidence, which rubric requirement it anchors to, the problem, the consequence, how to fix it, and references into the code. Plus a reviewer-audit block flagging what a human should double-check.</a:t>
+              <a:t>src/prompt is the grading protocol - eight files, and I would argue that is the real contribution. src/pipeline and src/workflows are twenty-three scripts: render prompts, call providers, validate outputs, compute statistics. And reproduce.py rebuilds the entire paper in one command.</a:t>
             </a:r>
           </a:p>
           <a:p/>
           <a:p>
             <a:r>
-              <a:t>Only then does stage two turn that validated JSON into feedback. It is told not to re-grade and not to look for new defects. It selects at most six high-confidence items and writes them for a first-year student.</a:t>
+              <a:t>Then the data: six run directories, two models times three repetitions. Each holds the anonymized submissions, the rubric, one thousand and eight rendered prompts - the exact bytes we sent - five hundred and four model assessments, the TA grades and the expert reference.</a:t>
             </a:r>
           </a:p>
           <a:p/>
           <a:p>
             <a:r>
-              <a:t>The split makes the two failure modes separable: when a grade is wrong, you can point at the deduction that caused it.</a:t>
-            </a:r>
-          </a:p>
-          <a:p/>
-          <a:p>
-            <a:r>
-              <a:t>(153 words / 65s window, budget 157)</a:t>
+              <a:t>(89 words / 35s window, budget 85)</a:t>
             </a:r>
           </a:p>
         </p:txBody>
@@ -1100,37 +1118,37 @@
           <a:lstStyle/>
           <a:p>
             <a:r>
-              <a:t>[02:55 - 03:55]  slide 05 of 11</a:t>
+              <a:t>[02:40 - 03:45]  slide 05 of 11</a:t>
             </a:r>
           </a:p>
           <a:p/>
           <a:p>
             <a:r>
-              <a:t>This is the part I would actually reuse, so let me be concrete. Nothing in that prompt directory is a finished prompt - they are templates with double-brace placeholders, filled at two distinct moments.</a:t>
+              <a:t>Now the prompt, because that is what people usually want to see. We split grading into two calls, deliberately.</a:t>
             </a:r>
           </a:p>
           <a:p/>
           <a:p>
             <a:r>
-              <a:t>At build time, the render script resolves nine slots for stage one: the specification, the grading reference, the starter scaffold, and the rubric - which is gated, so the script refuses to render if the rubric is not marked ready. Plus the course principles, the calibration examples and the schema. A hundred and thirty-six lines of template become a seventeen-hundred-line prompt.</a:t>
+              <a:t>Stage one is scoring only - the prompt forbids student-facing prose here. For every rubric criterion the model must return a score, positive evidence of learning, observations that should not cost points, and a list of deductions. Every deduction is structured: points lost, severity, confidence, which rubric requirement it anchors to, the problem, the consequence, how to fix it, and references into the code. Plus a reviewer-audit block flagging what a human should double-check.</a:t>
             </a:r>
           </a:p>
           <a:p/>
           <a:p>
             <a:r>
-              <a:t>Stage two is the interesting one. One placeholder is deliberately left unresolved on disk; at call time the runner parses the stage one response, re-serializes it, and only then injects it.</a:t>
+              <a:t>Only then does stage two turn that validated JSON into feedback. It is told not to re-grade and not to look for new defects. It selects at most six high-confidence items and writes them for a first-year student.</a:t>
             </a:r>
           </a:p>
           <a:p/>
           <a:p>
             <a:r>
-              <a:t>Two consequences. Stage two never sees raw model prose, only validated JSON. And since that substitution is the only non-static step, the prompts we ship are a faithful audit trail.</a:t>
+              <a:t>The split makes the two failure modes separable: when a grade is wrong, you can point at the deduction that caused it.</a:t>
             </a:r>
           </a:p>
           <a:p/>
           <a:p>
             <a:r>
-              <a:t>(156 words / 60s window, budget 145)</a:t>
+              <a:t>(153 words / 65s window, budget 157)</a:t>
             </a:r>
           </a:p>
         </p:txBody>
@@ -1200,31 +1218,37 @@
           <a:lstStyle/>
           <a:p>
             <a:r>
-              <a:t>[03:55 - 04:45]  slide 06 of 11</a:t>
+              <a:t>[03:45 - 04:45]  slide 06 of 11</a:t>
             </a:r>
           </a:p>
           <a:p/>
           <a:p>
             <a:r>
-              <a:t>The templates are only half of it. The other half is the guardrails, and every one of them exists because the model got something wrong without it.</a:t>
+              <a:t>This is the part I would actually reuse, so let me be concrete. Nothing in that prompt directory is a finished prompt - they are templates with double-brace placeholders, filled at two distinct moments.</a:t>
             </a:r>
           </a:p>
           <a:p/>
           <a:p>
             <a:r>
-              <a:t>We had to write, literally: do not convert optional improvements into point loss - route them to a separate non-penalized observations list. Avoid double jeopardy: if one root cause produces five symptoms, deduct once, on the criterion it most affects. Do not penalize naming, formatting, casing or punctuation. Here is the severity scale in actual points, because moderate means nothing on its own. And if confidence is low, keep it out of the student's feedback and log the omission for the reviewer.</a:t>
+              <a:t>At build time, the render script resolves nine slots for stage one: the specification, the grading reference, the starter scaffold, and the rubric - which is gated, so the script refuses to render if the rubric is not marked ready. Plus the course principles, the calibration examples and the schema. A hundred and thirty-six lines of template become a seventeen-hundred-line prompt.</a:t>
             </a:r>
           </a:p>
           <a:p/>
           <a:p>
             <a:r>
-              <a:t>The two JSON schemas are hard contracts, and the pipeline validates every single response against them.</a:t>
+              <a:t>Stage two is the interesting one. One placeholder is deliberately left unresolved on disk; at call time the runner parses the stage one response, re-serializes it, and only then injects it.</a:t>
             </a:r>
           </a:p>
           <a:p/>
           <a:p>
             <a:r>
-              <a:t>(125 words / 50s window, budget 121)</a:t>
+              <a:t>Two consequences. Stage two never sees raw model prose, only validated JSON. And since that substitution is the only non-static step, the prompts we ship are a faithful audit trail.</a:t>
+            </a:r>
+          </a:p>
+          <a:p/>
+          <a:p>
+            <a:r>
+              <a:t>(156 words / 60s window, budget 145)</a:t>
             </a:r>
           </a:p>
         </p:txBody>
@@ -1294,43 +1318,31 @@
           <a:lstStyle/>
           <a:p>
             <a:r>
-              <a:t>[04:45 - 05:30]  slide 07 of 11</a:t>
+              <a:t>[04:45 - 05:35]  slide 07 of 11</a:t>
             </a:r>
           </a:p>
           <a:p/>
           <a:p>
             <a:r>
-              <a:t>How the study was actually run, in three phases.</a:t>
+              <a:t>The templates are only half of it. The other half is the guardrails, and every one of them exists because the model got something wrong without it.</a:t>
             </a:r>
           </a:p>
           <a:p/>
           <a:p>
             <a:r>
-              <a:t>Phase one, inputs. Submissions are anonymized: author lines masked, repository names replaced, identifiers reduced to S01 through S84. No raw student repositories and no identity mapping ship in the artifact.</a:t>
+              <a:t>We had to write, literally: do not convert optional improvements into point loss - route them to a separate non-penalized observations list. Avoid double jeopardy: if one root cause produces five symptoms, deduct once, on the criterion it most affects. Do not penalize naming, formatting, casing or punctuation. Here is the severity scale in actual points, because moderate means nothing on its own. And if confidence is low, keep it out of the student's feedback and log the omission for the reviewer.</a:t>
             </a:r>
           </a:p>
           <a:p/>
           <a:p>
             <a:r>
-              <a:t>Phase two, evaluation. Three sources of judgement: the TA grades, which are the authentic operational baseline; an expert reference, meaning rubric scores plus three hundred sixty-one annotated issues over a twelve-category taxonomy; and the LLM assessments - both models, three runs each, five hundred and four assessments.</a:t>
+              <a:t>The two JSON schemas are hard contracts, and the pipeline validates every single response against them.</a:t>
             </a:r>
           </a:p>
           <a:p/>
           <a:p>
             <a:r>
-              <a:t>Phase three, the analyses for our two research questions, plus run-to-run stability.</a:t>
-            </a:r>
-          </a:p>
-          <a:p/>
-          <a:p>
-            <a:r>
-              <a:t>The detail I would highlight for reuse: every run directory is self-contained.</a:t>
-            </a:r>
-          </a:p>
-          <a:p/>
-          <a:p>
-            <a:r>
-              <a:t>(110 words / 45s window, budget 109)</a:t>
+              <a:t>(125 words / 50s window, budget 121)</a:t>
             </a:r>
           </a:p>
         </p:txBody>
@@ -1400,43 +1412,43 @@
           <a:lstStyle/>
           <a:p>
             <a:r>
-              <a:t>[05:30 - 06:10]  slide 08 of 11</a:t>
+              <a:t>[05:35 - 06:20]  slide 08 of 11</a:t>
             </a:r>
           </a:p>
           <a:p/>
           <a:p>
             <a:r>
-              <a:t>One measurement was genuinely hard.</a:t>
+              <a:t>How the study was actually run, in three phases.</a:t>
             </a:r>
           </a:p>
           <a:p/>
           <a:p>
             <a:r>
-              <a:t>To ask whether the model found the same problem as the expert, string equality is useless and taxonomy overlap is far too generous. Two evaluators describe one encapsulation defect in completely different words.</a:t>
+              <a:t>Phase one, inputs. Submissions are anonymized: author lines masked, repository names replaced, identifiers reduced to S01 through S84. No raw student repositories and no identity mapping ship in the artifact.</a:t>
             </a:r>
           </a:p>
           <a:p/>
           <a:p>
             <a:r>
-              <a:t>So we used a third model, Claude Sonnet 5, as adjudicator - from a provider family we were not evaluating, so neither model gets a home advantage. Matching is scoped to one submission and one criterion.</a:t>
+              <a:t>Phase two, evaluation. Three sources of judgement: the TA grades, which are the authentic operational baseline; an expert reference, meaning rubric scores plus three hundred sixty-one annotated issues over a twelve-category taxonomy; and the LLM assessments - both models, three runs each, five hundred and four assessments.</a:t>
             </a:r>
           </a:p>
           <a:p/>
           <a:p>
             <a:r>
-              <a:t>That is model-assisted labelling, so we call it operational matching, not ground truth. The prompt, the model identifier and every cache entry ship in the artifact.</a:t>
+              <a:t>Phase three, the analyses for our two research questions, plus run-to-run stability.</a:t>
             </a:r>
           </a:p>
           <a:p/>
           <a:p>
             <a:r>
-              <a:t>IF AHEAD: and there is a sensitivity check - reversing ten adjudicated matches shifts precision and recall by under four hundredths.</a:t>
+              <a:t>The detail I would highlight for reuse: every run directory is self-contained.</a:t>
             </a:r>
           </a:p>
           <a:p/>
           <a:p>
             <a:r>
-              <a:t>(100 words / 40s window, budget 97)</a:t>
+              <a:t>(110 words / 45s window, budget 109)</a:t>
             </a:r>
           </a:p>
         </p:txBody>
@@ -1506,43 +1518,43 @@
           <a:lstStyle/>
           <a:p>
             <a:r>
-              <a:t>[06:10 - 07:00]  slide 09 of 11</a:t>
+              <a:t>[06:20 - 07:00]  slide 09 of 11</a:t>
             </a:r>
           </a:p>
           <a:p/>
           <a:p>
             <a:r>
-              <a:t>The results, briefly.</a:t>
+              <a:t>One measurement was genuinely hard.</a:t>
             </a:r>
           </a:p>
           <a:p/>
           <a:p>
             <a:r>
-              <a:t>On grades, Gemini essentially matches the human baseline: mean absolute error of 0.44 against the expert reference, where the TAs themselves sit at 0.45. GPT-5.5 systematically undergrades, with a bias of minus 1.45.</a:t>
+              <a:t>To ask whether the model found the same problem as the expert, string equality is useless and taxonomy overlap is far too generous. Two evaluators describe one encapsulation defect in completely different words.</a:t>
             </a:r>
           </a:p>
           <a:p/>
           <a:p>
             <a:r>
-              <a:t>On diagnosis, the F1 scores are almost identical - 0.67 and 0.65 - and that similarity hides completely opposite behaviour. GPT-5.5 finds nearly every expert-annotated issue, recall 0.96, but about half of what it reports has no expert equivalent. Gemini is much cleaner and misses over a third of the issues.</a:t>
+              <a:t>So we used a third model, Claude Sonnet 5, as adjudicator - from a provider family we were not evaluating, so neither model gets a home advantage. Matching is scoped to one submission and one criterion.</a:t>
             </a:r>
           </a:p>
           <a:p/>
           <a:p>
             <a:r>
-              <a:t>And stability: both models rank submissions consistently, ICC around 0.9, yet exact agreement across three runs is two percent and zero.</a:t>
+              <a:t>That is model-assisted labelling, so we call it operational matching, not ground truth. The prompt, the model identifier and every cache entry ship in the artifact.</a:t>
             </a:r>
           </a:p>
           <a:p/>
           <a:p>
             <a:r>
-              <a:t>Same aggregate F1, a different assessment instrument. That is the title.</a:t>
+              <a:t>IF AHEAD: and there is a sensitivity check - reversing ten adjudicated matches shifts precision and recall by under four hundredths.</a:t>
             </a:r>
           </a:p>
           <a:p/>
           <a:p>
             <a:r>
-              <a:t>(119 words / 50s window, budget 121)</a:t>
+              <a:t>(100 words / 40s window, budget 97)</a:t>
             </a:r>
           </a:p>
         </p:txBody>
@@ -5629,7 +5641,7 @@
                 </a:solidFill>
                 <a:latin typeface="Public Sans"/>
               </a:rPr>
-              <a:t>WHY THIS ARTIFACT EXISTS</a:t>
+              <a:t>THE PAPER BEHIND THE ARTIFACT</a:t>
             </a:r>
           </a:p>
         </p:txBody>
@@ -5697,39 +5709,55 @@
               </a:lnSpc>
             </a:pPr>
             <a:r>
-              <a:rPr sz="1542" b="0" i="0">
-                <a:solidFill>
-                  <a:srgbClr val="2B2C30"/>
-                </a:solidFill>
-                <a:latin typeface="Courier New"/>
-              </a:rPr>
-              <a:t>In a design-oriented OOP assignment, correctness and design do not</a:t>
-            </a:r>
-          </a:p>
-          <a:p>
-            <a:pPr algn="l">
-              <a:lnSpc>
-                <a:spcPct val="118000"/>
-              </a:lnSpc>
-            </a:pPr>
-            <a:r>
-              <a:rPr sz="1542" b="0" i="0">
-                <a:solidFill>
-                  <a:srgbClr val="2B2C30"/>
-                </a:solidFill>
-                <a:latin typeface="Courier New"/>
-              </a:rPr>
-              <a:t>always agree:</a:t>
-            </a:r>
-          </a:p>
-          <a:p>
-            <a:pPr algn="l">
-              <a:lnSpc>
-                <a:spcPct val="118000"/>
-              </a:lnSpc>
-            </a:pPr>
-            <a:r>
-              <a:rPr sz="1542" b="0" i="0">
+              <a:rPr sz="1311" b="0" i="0">
+                <a:solidFill>
+                  <a:srgbClr val="2B2C30"/>
+                </a:solidFill>
+                <a:latin typeface="Courier New"/>
+              </a:rPr>
+              <a:t>The paper is an evaluation protocol for LLM-assisted assessment of</a:t>
+            </a:r>
+          </a:p>
+          <a:p>
+            <a:pPr algn="l">
+              <a:lnSpc>
+                <a:spcPct val="118000"/>
+              </a:lnSpc>
+            </a:pPr>
+            <a:r>
+              <a:rPr sz="1311" b="0" i="0">
+                <a:solidFill>
+                  <a:srgbClr val="2B2C30"/>
+                </a:solidFill>
+                <a:latin typeface="Courier New"/>
+              </a:rPr>
+              <a:t>design-oriented OOP assignments. The artifact is that protocol, made</a:t>
+            </a:r>
+          </a:p>
+          <a:p>
+            <a:pPr algn="l">
+              <a:lnSpc>
+                <a:spcPct val="118000"/>
+              </a:lnSpc>
+            </a:pPr>
+            <a:r>
+              <a:rPr sz="1311" b="0" i="0">
+                <a:solidFill>
+                  <a:srgbClr val="2B2C30"/>
+                </a:solidFill>
+                <a:latin typeface="Courier New"/>
+              </a:rPr>
+              <a:t>runnable.</a:t>
+            </a:r>
+          </a:p>
+          <a:p>
+            <a:pPr algn="l">
+              <a:lnSpc>
+                <a:spcPct val="118000"/>
+              </a:lnSpc>
+            </a:pPr>
+            <a:r>
+              <a:rPr sz="1311" b="0" i="0">
                 <a:solidFill>
                   <a:srgbClr val="2B2C30"/>
                 </a:solidFill>
@@ -5745,39 +5773,23 @@
               </a:lnSpc>
             </a:pPr>
             <a:r>
-              <a:rPr sz="1542" b="0" i="0">
-                <a:solidFill>
-                  <a:srgbClr val="2B2C30"/>
-                </a:solidFill>
-                <a:latin typeface="Courier New"/>
-              </a:rPr>
-              <a:t>  submission A   every feature works   -&gt;  one 400-line class,</a:t>
-            </a:r>
-          </a:p>
-          <a:p>
-            <a:pPr algn="l">
-              <a:lnSpc>
-                <a:spcPct val="118000"/>
-              </a:lnSpc>
-            </a:pPr>
-            <a:r>
-              <a:rPr sz="1542" b="0" i="0">
-                <a:solidFill>
-                  <a:srgbClr val="2B2C30"/>
-                </a:solidFill>
-                <a:latin typeface="Courier New"/>
-              </a:rPr>
-              <a:t>                                            no domain objects</a:t>
-            </a:r>
-          </a:p>
-          <a:p>
-            <a:pPr algn="l">
-              <a:lnSpc>
-                <a:spcPct val="118000"/>
-              </a:lnSpc>
-            </a:pPr>
-            <a:r>
-              <a:rPr sz="1542" b="0" i="0">
+              <a:rPr sz="1311" b="0" i="0">
+                <a:solidFill>
+                  <a:srgbClr val="2B2C30"/>
+                </a:solidFill>
+                <a:latin typeface="Courier New"/>
+              </a:rPr>
+              <a:t>  a single score merges two capabilities the paper keeps apart:</a:t>
+            </a:r>
+          </a:p>
+          <a:p>
+            <a:pPr algn="l">
+              <a:lnSpc>
+                <a:spcPct val="118000"/>
+              </a:lnSpc>
+            </a:pPr>
+            <a:r>
+              <a:rPr sz="1311" b="0" i="0">
                 <a:solidFill>
                   <a:srgbClr val="2B2C30"/>
                 </a:solidFill>
@@ -5793,39 +5805,103 @@
               </a:lnSpc>
             </a:pPr>
             <a:r>
-              <a:rPr sz="1542" b="0" i="0">
-                <a:solidFill>
-                  <a:srgbClr val="2B2C30"/>
-                </a:solidFill>
-                <a:latin typeface="Courier New"/>
-              </a:rPr>
-              <a:t>  submission B   one off-by-one bug    -&gt;  clean class modeling,</a:t>
-            </a:r>
-          </a:p>
-          <a:p>
-            <a:pPr algn="l">
-              <a:lnSpc>
-                <a:spcPct val="118000"/>
-              </a:lnSpc>
-            </a:pPr>
-            <a:r>
-              <a:rPr sz="1542" b="0" i="0">
-                <a:solidFill>
-                  <a:srgbClr val="2B2C30"/>
-                </a:solidFill>
-                <a:latin typeface="Courier New"/>
-              </a:rPr>
-              <a:t>                                            responsibilities split</a:t>
-            </a:r>
-          </a:p>
-          <a:p>
-            <a:pPr algn="l">
-              <a:lnSpc>
-                <a:spcPct val="118000"/>
-              </a:lnSpc>
-            </a:pPr>
-            <a:r>
-              <a:rPr sz="1542" b="0" i="0">
+              <a:rPr sz="1311" b="0" i="0">
+                <a:solidFill>
+                  <a:srgbClr val="2B2C30"/>
+                </a:solidFill>
+                <a:latin typeface="Courier New"/>
+              </a:rPr>
+              <a:t>  +-------------------------------+  +-------------------------------+</a:t>
+            </a:r>
+          </a:p>
+          <a:p>
+            <a:pPr algn="l">
+              <a:lnSpc>
+                <a:spcPct val="118000"/>
+              </a:lnSpc>
+            </a:pPr>
+            <a:r>
+              <a:rPr sz="1311" b="0" i="0">
+                <a:solidFill>
+                  <a:srgbClr val="2B2C30"/>
+                </a:solidFill>
+                <a:latin typeface="Courier New"/>
+              </a:rPr>
+              <a:t>  |  GRADE CONCORDANCE            |  |  DIAGNOSTIC ALIGNMENT         |</a:t>
+            </a:r>
+          </a:p>
+          <a:p>
+            <a:pPr algn="l">
+              <a:lnSpc>
+                <a:spcPct val="118000"/>
+              </a:lnSpc>
+            </a:pPr>
+            <a:r>
+              <a:rPr sz="1311" b="0" i="0">
+                <a:solidFill>
+                  <a:srgbClr val="2B2C30"/>
+                </a:solidFill>
+                <a:latin typeface="Courier New"/>
+              </a:rPr>
+              <a:t>  |                               |  |                               |</a:t>
+            </a:r>
+          </a:p>
+          <a:p>
+            <a:pPr algn="l">
+              <a:lnSpc>
+                <a:spcPct val="118000"/>
+              </a:lnSpc>
+            </a:pPr>
+            <a:r>
+              <a:rPr sz="1311" b="0" i="0">
+                <a:solidFill>
+                  <a:srgbClr val="2B2C30"/>
+                </a:solidFill>
+                <a:latin typeface="Courier New"/>
+              </a:rPr>
+              <a:t>  |  does the score match the     |  |  does it name the same        |</a:t>
+            </a:r>
+          </a:p>
+          <a:p>
+            <a:pPr algn="l">
+              <a:lnSpc>
+                <a:spcPct val="118000"/>
+              </a:lnSpc>
+            </a:pPr>
+            <a:r>
+              <a:rPr sz="1311" b="0" i="0">
+                <a:solidFill>
+                  <a:srgbClr val="2B2C30"/>
+                </a:solidFill>
+                <a:latin typeface="Courier New"/>
+              </a:rPr>
+              <a:t>  |  human baseline?              |  |  problems an expert found?    |</a:t>
+            </a:r>
+          </a:p>
+          <a:p>
+            <a:pPr algn="l">
+              <a:lnSpc>
+                <a:spcPct val="118000"/>
+              </a:lnSpc>
+            </a:pPr>
+            <a:r>
+              <a:rPr sz="1311" b="0" i="0">
+                <a:solidFill>
+                  <a:srgbClr val="2B2C30"/>
+                </a:solidFill>
+                <a:latin typeface="Courier New"/>
+              </a:rPr>
+              <a:t>  +-------------------------------+  +-------------------------------+</a:t>
+            </a:r>
+          </a:p>
+          <a:p>
+            <a:pPr algn="l">
+              <a:lnSpc>
+                <a:spcPct val="118000"/>
+              </a:lnSpc>
+            </a:pPr>
+            <a:r>
+              <a:rPr sz="1311" b="0" i="0">
                 <a:solidFill>
                   <a:srgbClr val="2B2C30"/>
                 </a:solidFill>
@@ -5841,23 +5917,39 @@
               </a:lnSpc>
             </a:pPr>
             <a:r>
-              <a:rPr sz="1542" b="0" i="0">
-                <a:solidFill>
-                  <a:srgbClr val="2B2C30"/>
-                </a:solidFill>
-                <a:latin typeface="Courier New"/>
-              </a:rPr>
-              <a:t>Unit tests and static analysis rank A above B. An instructor does not.</a:t>
-            </a:r>
-          </a:p>
-          <a:p>
-            <a:pPr algn="l">
-              <a:lnSpc>
-                <a:spcPct val="118000"/>
-              </a:lnSpc>
-            </a:pPr>
-            <a:r>
-              <a:rPr sz="1542" b="0" i="0">
+              <a:rPr sz="1311" b="0" i="0">
+                <a:solidFill>
+                  <a:srgbClr val="2B2C30"/>
+                </a:solidFill>
+                <a:latin typeface="Courier New"/>
+              </a:rPr>
+              <a:t>     measured separately, against human references, on the same</a:t>
+            </a:r>
+          </a:p>
+          <a:p>
+            <a:pPr algn="l">
+              <a:lnSpc>
+                <a:spcPct val="118000"/>
+              </a:lnSpc>
+            </a:pPr>
+            <a:r>
+              <a:rPr sz="1311" b="0" i="0">
+                <a:solidFill>
+                  <a:srgbClr val="2B2C30"/>
+                </a:solidFill>
+                <a:latin typeface="Courier New"/>
+              </a:rPr>
+              <a:t>     submissions, under one fixed prompt protocol</a:t>
+            </a:r>
+          </a:p>
+          <a:p>
+            <a:pPr algn="l">
+              <a:lnSpc>
+                <a:spcPct val="118000"/>
+              </a:lnSpc>
+            </a:pPr>
+            <a:r>
+              <a:rPr sz="1311" b="0" i="0">
                 <a:solidFill>
                   <a:srgbClr val="2B2C30"/>
                 </a:solidFill>
@@ -5873,23 +5965,39 @@
               </a:lnSpc>
             </a:pPr>
             <a:r>
-              <a:rPr sz="1542" b="0" i="0">
-                <a:solidFill>
-                  <a:srgbClr val="2B2C30"/>
-                </a:solidFill>
-                <a:latin typeface="Courier New"/>
-              </a:rPr>
-              <a:t>So this kind of assessment stays manual:</a:t>
-            </a:r>
-          </a:p>
-          <a:p>
-            <a:pPr algn="l">
-              <a:lnSpc>
-                <a:spcPct val="118000"/>
-              </a:lnSpc>
-            </a:pPr>
-            <a:r>
-              <a:rPr sz="1542" b="0" i="0">
+              <a:rPr sz="1311" b="0" i="0">
+                <a:solidFill>
+                  <a:srgbClr val="2B2C30"/>
+                </a:solidFill>
+                <a:latin typeface="Courier New"/>
+              </a:rPr>
+              <a:t>Same assignment, same rubric, same prompt structure, same output schema,</a:t>
+            </a:r>
+          </a:p>
+          <a:p>
+            <a:pPr algn="l">
+              <a:lnSpc>
+                <a:spcPct val="118000"/>
+              </a:lnSpc>
+            </a:pPr>
+            <a:r>
+              <a:rPr sz="1311" b="0" i="0">
+                <a:solidFill>
+                  <a:srgbClr val="2B2C30"/>
+                </a:solidFill>
+                <a:latin typeface="Courier New"/>
+              </a:rPr>
+              <a:t>for every model and every repetition.</a:t>
+            </a:r>
+          </a:p>
+          <a:p>
+            <a:pPr algn="l">
+              <a:lnSpc>
+                <a:spcPct val="118000"/>
+              </a:lnSpc>
+            </a:pPr>
+            <a:r>
+              <a:rPr sz="1311" b="0" i="0">
                 <a:solidFill>
                   <a:srgbClr val="2B2C30"/>
                 </a:solidFill>
@@ -5905,61 +6013,13 @@
               </a:lnSpc>
             </a:pPr>
             <a:r>
-              <a:rPr sz="1542" b="0" i="0">
-                <a:solidFill>
-                  <a:srgbClr val="2B2C30"/>
-                </a:solidFill>
-                <a:latin typeface="Courier New"/>
-              </a:rPr>
-              <a:t>  84 submissions  x  7 rubric criteria  x  written feedback</a:t>
-            </a:r>
-          </a:p>
-          <a:p>
-            <a:pPr algn="l">
-              <a:lnSpc>
-                <a:spcPct val="118000"/>
-              </a:lnSpc>
-            </a:pPr>
-            <a:r>
-              <a:rPr sz="1542" b="0" i="0">
-                <a:solidFill>
-                  <a:srgbClr val="2B2C30"/>
-                </a:solidFill>
-                <a:latin typeface="Courier New"/>
-              </a:rPr>
-              <a:t>  graded by 28 teaching assistants, 1 to 6 submissions each</a:t>
-            </a:r>
-          </a:p>
-          <a:p>
-            <a:pPr algn="l">
-              <a:lnSpc>
-                <a:spcPct val="118000"/>
-              </a:lnSpc>
-            </a:pPr>
-            <a:r>
-              <a:rPr sz="1542" b="0" i="0">
-                <a:solidFill>
-                  <a:srgbClr val="2B2C30"/>
-                </a:solidFill>
-                <a:latin typeface="Courier New"/>
-              </a:rPr>
-              <a:t/>
-            </a:r>
-          </a:p>
-          <a:p>
-            <a:pPr algn="l">
-              <a:lnSpc>
-                <a:spcPct val="118000"/>
-              </a:lnSpc>
-            </a:pPr>
-            <a:r>
-              <a:rPr sz="1542" b="0" i="0">
-                <a:solidFill>
-                  <a:srgbClr val="2B2C30"/>
-                </a:solidFill>
-                <a:latin typeface="Courier New"/>
-              </a:rPr>
-              <a:t>Can an LLM help here?  And how would we measure "help" at all?</a:t>
+              <a:rPr sz="1311" b="0" i="0">
+                <a:solidFill>
+                  <a:srgbClr val="2B2C30"/>
+                </a:solidFill>
+                <a:latin typeface="Courier New"/>
+              </a:rPr>
+              <a:t>Grading is easy. Feedback is hard.</a:t>
             </a:r>
           </a:p>
         </p:txBody>
@@ -6054,7 +6114,7 @@
                 </a:solidFill>
                 <a:latin typeface="Public Sans"/>
               </a:rPr>
-              <a:t>WHAT IS INSIDE THE ARTIFACT</a:t>
+              <a:t>WHY THIS ARTIFACT EXISTS</a:t>
             </a:r>
           </a:p>
         </p:txBody>
@@ -6122,231 +6182,39 @@
               </a:lnSpc>
             </a:pPr>
             <a:r>
-              <a:rPr sz="1600" b="0" i="0">
-                <a:solidFill>
-                  <a:srgbClr val="2B2C30"/>
-                </a:solidFill>
-                <a:latin typeface="Courier New"/>
-              </a:rPr>
-              <a:t>.</a:t>
-            </a:r>
-          </a:p>
-          <a:p>
-            <a:pPr algn="l">
-              <a:lnSpc>
-                <a:spcPct val="118000"/>
-              </a:lnSpc>
-            </a:pPr>
-            <a:r>
-              <a:rPr sz="1600" b="0" i="0">
-                <a:solidFill>
-                  <a:srgbClr val="2B2C30"/>
-                </a:solidFill>
-                <a:latin typeface="Courier New"/>
-              </a:rPr>
-              <a:t>|-- src/prompt/            8 files     the grading protocol itself</a:t>
-            </a:r>
-          </a:p>
-          <a:p>
-            <a:pPr algn="l">
-              <a:lnSpc>
-                <a:spcPct val="118000"/>
-              </a:lnSpc>
-            </a:pPr>
-            <a:r>
-              <a:rPr sz="1600" b="0" i="0">
-                <a:solidFill>
-                  <a:srgbClr val="2B2C30"/>
-                </a:solidFill>
-                <a:latin typeface="Courier New"/>
-              </a:rPr>
-              <a:t>|-- src/pipeline/         18 scripts   render, run, validate, analyse</a:t>
-            </a:r>
-          </a:p>
-          <a:p>
-            <a:pPr algn="l">
-              <a:lnSpc>
-                <a:spcPct val="118000"/>
-              </a:lnSpc>
-            </a:pPr>
-            <a:r>
-              <a:rPr sz="1600" b="0" i="0">
-                <a:solidFill>
-                  <a:srgbClr val="2B2C30"/>
-                </a:solidFill>
-                <a:latin typeface="Courier New"/>
-              </a:rPr>
-              <a:t>|-- src/workflows/         5 scripts   stage orchestration</a:t>
-            </a:r>
-          </a:p>
-          <a:p>
-            <a:pPr algn="l">
-              <a:lnSpc>
-                <a:spcPct val="118000"/>
-              </a:lnSpc>
-            </a:pPr>
-            <a:r>
-              <a:rPr sz="1600" b="0" i="0">
-                <a:solidFill>
-                  <a:srgbClr val="2B2C30"/>
-                </a:solidFill>
-                <a:latin typeface="Courier New"/>
-              </a:rPr>
-              <a:t>|-- src/reproduce.py       1 command   the whole paper, no API keys</a:t>
-            </a:r>
-          </a:p>
-          <a:p>
-            <a:pPr algn="l">
-              <a:lnSpc>
-                <a:spcPct val="118000"/>
-              </a:lnSpc>
-            </a:pPr>
-            <a:r>
-              <a:rPr sz="1600" b="0" i="0">
-                <a:solidFill>
-                  <a:srgbClr val="2B2C30"/>
-                </a:solidFill>
-                <a:latin typeface="Courier New"/>
-              </a:rPr>
-              <a:t>|-- data/lab03-filmnow/</a:t>
-            </a:r>
-          </a:p>
-          <a:p>
-            <a:pPr algn="l">
-              <a:lnSpc>
-                <a:spcPct val="118000"/>
-              </a:lnSpc>
-            </a:pPr>
-            <a:r>
-              <a:rPr sz="1600" b="0" i="0">
-                <a:solidFill>
-                  <a:srgbClr val="2B2C30"/>
-                </a:solidFill>
-                <a:latin typeface="Courier New"/>
-              </a:rPr>
-              <a:t>|   |-- runs/              6 runs      2 models x 3 repetitions</a:t>
-            </a:r>
-          </a:p>
-          <a:p>
-            <a:pPr algn="l">
-              <a:lnSpc>
-                <a:spcPct val="118000"/>
-              </a:lnSpc>
-            </a:pPr>
-            <a:r>
-              <a:rPr sz="1600" b="0" i="0">
-                <a:solidFill>
-                  <a:srgbClr val="2B2C30"/>
-                </a:solidFill>
-                <a:latin typeface="Courier New"/>
-              </a:rPr>
-              <a:t>|   |     inputs/          84 anonymized Java submissions + rubric</a:t>
-            </a:r>
-          </a:p>
-          <a:p>
-            <a:pPr algn="l">
-              <a:lnSpc>
-                <a:spcPct val="118000"/>
-              </a:lnSpc>
-            </a:pPr>
-            <a:r>
-              <a:rPr sz="1600" b="0" i="0">
-                <a:solidFill>
-                  <a:srgbClr val="2B2C30"/>
-                </a:solidFill>
-                <a:latin typeface="Courier New"/>
-              </a:rPr>
-              <a:t>|   |     prompts/         1008 rendered prompts, the exact bytes sent</a:t>
-            </a:r>
-          </a:p>
-          <a:p>
-            <a:pPr algn="l">
-              <a:lnSpc>
-                <a:spcPct val="118000"/>
-              </a:lnSpc>
-            </a:pPr>
-            <a:r>
-              <a:rPr sz="1600" b="0" i="0">
-                <a:solidFill>
-                  <a:srgbClr val="2B2C30"/>
-                </a:solidFill>
-                <a:latin typeface="Courier New"/>
-              </a:rPr>
-              <a:t>|   |     outputs/         504 LLM assessments + TA + expert reference</a:t>
-            </a:r>
-          </a:p>
-          <a:p>
-            <a:pPr algn="l">
-              <a:lnSpc>
-                <a:spcPct val="118000"/>
-              </a:lnSpc>
-            </a:pPr>
-            <a:r>
-              <a:rPr sz="1600" b="0" i="0">
-                <a:solidFill>
-                  <a:srgbClr val="2B2C30"/>
-                </a:solidFill>
-                <a:latin typeface="Courier New"/>
-              </a:rPr>
-              <a:t>|   |     analyses/        per-run metrics + semantic-match caches</a:t>
-            </a:r>
-          </a:p>
-          <a:p>
-            <a:pPr algn="l">
-              <a:lnSpc>
-                <a:spcPct val="118000"/>
-              </a:lnSpc>
-            </a:pPr>
-            <a:r>
-              <a:rPr sz="1600" b="0" i="0">
-                <a:solidFill>
-                  <a:srgbClr val="2B2C30"/>
-                </a:solidFill>
-                <a:latin typeface="Courier New"/>
-              </a:rPr>
-              <a:t>|   |-- results/           benchmark, stability, by_category</a:t>
-            </a:r>
-          </a:p>
-          <a:p>
-            <a:pPr algn="l">
-              <a:lnSpc>
-                <a:spcPct val="118000"/>
-              </a:lnSpc>
-            </a:pPr>
-            <a:r>
-              <a:rPr sz="1600" b="0" i="0">
-                <a:solidFill>
-                  <a:srgbClr val="2B2C30"/>
-                </a:solidFill>
-                <a:latin typeface="Courier New"/>
-              </a:rPr>
-              <a:t>|   `-- study/             three-run manifests</a:t>
-            </a:r>
-          </a:p>
-          <a:p>
-            <a:pPr algn="l">
-              <a:lnSpc>
-                <a:spcPct val="118000"/>
-              </a:lnSpc>
-            </a:pPr>
-            <a:r>
-              <a:rPr sz="1600" b="0" i="0">
-                <a:solidFill>
-                  <a:srgbClr val="2B2C30"/>
-                </a:solidFill>
-                <a:latin typeface="Courier New"/>
-              </a:rPr>
-              <a:t>`-- docs/                  paper PDF, 13 figures, 13 tables, 3 TikZ</a:t>
-            </a:r>
-          </a:p>
-          <a:p>
-            <a:pPr algn="l">
-              <a:lnSpc>
-                <a:spcPct val="118000"/>
-              </a:lnSpc>
-            </a:pPr>
-            <a:r>
-              <a:rPr sz="1600" b="0" i="0">
+              <a:rPr sz="1542" b="0" i="0">
+                <a:solidFill>
+                  <a:srgbClr val="2B2C30"/>
+                </a:solidFill>
+                <a:latin typeface="Courier New"/>
+              </a:rPr>
+              <a:t>In a design-oriented OOP assignment, correctness and design do not</a:t>
+            </a:r>
+          </a:p>
+          <a:p>
+            <a:pPr algn="l">
+              <a:lnSpc>
+                <a:spcPct val="118000"/>
+              </a:lnSpc>
+            </a:pPr>
+            <a:r>
+              <a:rPr sz="1542" b="0" i="0">
+                <a:solidFill>
+                  <a:srgbClr val="2B2C30"/>
+                </a:solidFill>
+                <a:latin typeface="Courier New"/>
+              </a:rPr>
+              <a:t>always agree:</a:t>
+            </a:r>
+          </a:p>
+          <a:p>
+            <a:pPr algn="l">
+              <a:lnSpc>
+                <a:spcPct val="118000"/>
+              </a:lnSpc>
+            </a:pPr>
+            <a:r>
+              <a:rPr sz="1542" b="0" i="0">
                 <a:solidFill>
                   <a:srgbClr val="2B2C30"/>
                 </a:solidFill>
@@ -6362,13 +6230,221 @@
               </a:lnSpc>
             </a:pPr>
             <a:r>
-              <a:rPr sz="1600" b="0" i="0">
-                <a:solidFill>
-                  <a:srgbClr val="2B2C30"/>
-                </a:solidFill>
-                <a:latin typeface="Courier New"/>
-              </a:rPr>
-              <a:t>~10k lines of Python  .  132 MB of data  .  all of it regenerable</a:t>
+              <a:rPr sz="1542" b="0" i="0">
+                <a:solidFill>
+                  <a:srgbClr val="2B2C30"/>
+                </a:solidFill>
+                <a:latin typeface="Courier New"/>
+              </a:rPr>
+              <a:t>  submission A   every feature works   -&gt;  one 400-line class,</a:t>
+            </a:r>
+          </a:p>
+          <a:p>
+            <a:pPr algn="l">
+              <a:lnSpc>
+                <a:spcPct val="118000"/>
+              </a:lnSpc>
+            </a:pPr>
+            <a:r>
+              <a:rPr sz="1542" b="0" i="0">
+                <a:solidFill>
+                  <a:srgbClr val="2B2C30"/>
+                </a:solidFill>
+                <a:latin typeface="Courier New"/>
+              </a:rPr>
+              <a:t>                                            no domain objects</a:t>
+            </a:r>
+          </a:p>
+          <a:p>
+            <a:pPr algn="l">
+              <a:lnSpc>
+                <a:spcPct val="118000"/>
+              </a:lnSpc>
+            </a:pPr>
+            <a:r>
+              <a:rPr sz="1542" b="0" i="0">
+                <a:solidFill>
+                  <a:srgbClr val="2B2C30"/>
+                </a:solidFill>
+                <a:latin typeface="Courier New"/>
+              </a:rPr>
+              <a:t/>
+            </a:r>
+          </a:p>
+          <a:p>
+            <a:pPr algn="l">
+              <a:lnSpc>
+                <a:spcPct val="118000"/>
+              </a:lnSpc>
+            </a:pPr>
+            <a:r>
+              <a:rPr sz="1542" b="0" i="0">
+                <a:solidFill>
+                  <a:srgbClr val="2B2C30"/>
+                </a:solidFill>
+                <a:latin typeface="Courier New"/>
+              </a:rPr>
+              <a:t>  submission B   one off-by-one bug    -&gt;  clean class modeling,</a:t>
+            </a:r>
+          </a:p>
+          <a:p>
+            <a:pPr algn="l">
+              <a:lnSpc>
+                <a:spcPct val="118000"/>
+              </a:lnSpc>
+            </a:pPr>
+            <a:r>
+              <a:rPr sz="1542" b="0" i="0">
+                <a:solidFill>
+                  <a:srgbClr val="2B2C30"/>
+                </a:solidFill>
+                <a:latin typeface="Courier New"/>
+              </a:rPr>
+              <a:t>                                            responsibilities split</a:t>
+            </a:r>
+          </a:p>
+          <a:p>
+            <a:pPr algn="l">
+              <a:lnSpc>
+                <a:spcPct val="118000"/>
+              </a:lnSpc>
+            </a:pPr>
+            <a:r>
+              <a:rPr sz="1542" b="0" i="0">
+                <a:solidFill>
+                  <a:srgbClr val="2B2C30"/>
+                </a:solidFill>
+                <a:latin typeface="Courier New"/>
+              </a:rPr>
+              <a:t/>
+            </a:r>
+          </a:p>
+          <a:p>
+            <a:pPr algn="l">
+              <a:lnSpc>
+                <a:spcPct val="118000"/>
+              </a:lnSpc>
+            </a:pPr>
+            <a:r>
+              <a:rPr sz="1542" b="0" i="0">
+                <a:solidFill>
+                  <a:srgbClr val="2B2C30"/>
+                </a:solidFill>
+                <a:latin typeface="Courier New"/>
+              </a:rPr>
+              <a:t>Unit tests and static analysis rank A above B. An instructor does not.</a:t>
+            </a:r>
+          </a:p>
+          <a:p>
+            <a:pPr algn="l">
+              <a:lnSpc>
+                <a:spcPct val="118000"/>
+              </a:lnSpc>
+            </a:pPr>
+            <a:r>
+              <a:rPr sz="1542" b="0" i="0">
+                <a:solidFill>
+                  <a:srgbClr val="2B2C30"/>
+                </a:solidFill>
+                <a:latin typeface="Courier New"/>
+              </a:rPr>
+              <a:t/>
+            </a:r>
+          </a:p>
+          <a:p>
+            <a:pPr algn="l">
+              <a:lnSpc>
+                <a:spcPct val="118000"/>
+              </a:lnSpc>
+            </a:pPr>
+            <a:r>
+              <a:rPr sz="1542" b="0" i="0">
+                <a:solidFill>
+                  <a:srgbClr val="2B2C30"/>
+                </a:solidFill>
+                <a:latin typeface="Courier New"/>
+              </a:rPr>
+              <a:t>So this kind of assessment stays manual:</a:t>
+            </a:r>
+          </a:p>
+          <a:p>
+            <a:pPr algn="l">
+              <a:lnSpc>
+                <a:spcPct val="118000"/>
+              </a:lnSpc>
+            </a:pPr>
+            <a:r>
+              <a:rPr sz="1542" b="0" i="0">
+                <a:solidFill>
+                  <a:srgbClr val="2B2C30"/>
+                </a:solidFill>
+                <a:latin typeface="Courier New"/>
+              </a:rPr>
+              <a:t/>
+            </a:r>
+          </a:p>
+          <a:p>
+            <a:pPr algn="l">
+              <a:lnSpc>
+                <a:spcPct val="118000"/>
+              </a:lnSpc>
+            </a:pPr>
+            <a:r>
+              <a:rPr sz="1542" b="0" i="0">
+                <a:solidFill>
+                  <a:srgbClr val="2B2C30"/>
+                </a:solidFill>
+                <a:latin typeface="Courier New"/>
+              </a:rPr>
+              <a:t>  84 submissions  x  7 rubric criteria  x  written feedback</a:t>
+            </a:r>
+          </a:p>
+          <a:p>
+            <a:pPr algn="l">
+              <a:lnSpc>
+                <a:spcPct val="118000"/>
+              </a:lnSpc>
+            </a:pPr>
+            <a:r>
+              <a:rPr sz="1542" b="0" i="0">
+                <a:solidFill>
+                  <a:srgbClr val="2B2C30"/>
+                </a:solidFill>
+                <a:latin typeface="Courier New"/>
+              </a:rPr>
+              <a:t>  graded by 28 teaching assistants, 1 to 6 submissions each</a:t>
+            </a:r>
+          </a:p>
+          <a:p>
+            <a:pPr algn="l">
+              <a:lnSpc>
+                <a:spcPct val="118000"/>
+              </a:lnSpc>
+            </a:pPr>
+            <a:r>
+              <a:rPr sz="1542" b="0" i="0">
+                <a:solidFill>
+                  <a:srgbClr val="2B2C30"/>
+                </a:solidFill>
+                <a:latin typeface="Courier New"/>
+              </a:rPr>
+              <a:t/>
+            </a:r>
+          </a:p>
+          <a:p>
+            <a:pPr algn="l">
+              <a:lnSpc>
+                <a:spcPct val="118000"/>
+              </a:lnSpc>
+            </a:pPr>
+            <a:r>
+              <a:rPr sz="1542" b="0" i="0">
+                <a:solidFill>
+                  <a:srgbClr val="2B2C30"/>
+                </a:solidFill>
+                <a:latin typeface="Courier New"/>
+              </a:rPr>
+              <a:t>Can an LLM help here?  And how would we measure "help" at all?</a:t>
             </a:r>
           </a:p>
         </p:txBody>
@@ -6463,7 +6539,7 @@
                 </a:solidFill>
                 <a:latin typeface="Public Sans"/>
               </a:rPr>
-              <a:t>THE PROMPT (1/3): TWO STAGES, ON PURPOSE</a:t>
+              <a:t>WHAT IS INSIDE THE ARTIFACT</a:t>
             </a:r>
           </a:p>
         </p:txBody>
@@ -6531,407 +6607,231 @@
               </a:lnSpc>
             </a:pPr>
             <a:r>
-              <a:rPr sz="971" b="0" i="0">
-                <a:solidFill>
-                  <a:srgbClr val="2B2C30"/>
-                </a:solidFill>
-                <a:latin typeface="Courier New"/>
-              </a:rPr>
-              <a:t>  assignment spec + official grading reference + starter scaffold</a:t>
-            </a:r>
-          </a:p>
-          <a:p>
-            <a:pPr algn="l">
-              <a:lnSpc>
-                <a:spcPct val="118000"/>
-              </a:lnSpc>
-            </a:pPr>
-            <a:r>
-              <a:rPr sz="971" b="0" i="0">
-                <a:solidFill>
-                  <a:srgbClr val="2B2C30"/>
-                </a:solidFill>
-                <a:latin typeface="Courier New"/>
-              </a:rPr>
-              <a:t>  + rubric.json + course principles + calibration examples</a:t>
-            </a:r>
-          </a:p>
-          <a:p>
-            <a:pPr algn="l">
-              <a:lnSpc>
-                <a:spcPct val="118000"/>
-              </a:lnSpc>
-            </a:pPr>
-            <a:r>
-              <a:rPr sz="971" b="0" i="0">
-                <a:solidFill>
-                  <a:srgbClr val="2B2C30"/>
-                </a:solidFill>
-                <a:latin typeface="Courier New"/>
-              </a:rPr>
-              <a:t>  + anonymized submission package</a:t>
-            </a:r>
-          </a:p>
-          <a:p>
-            <a:pPr algn="l">
-              <a:lnSpc>
-                <a:spcPct val="118000"/>
-              </a:lnSpc>
-            </a:pPr>
-            <a:r>
-              <a:rPr sz="971" b="0" i="0">
-                <a:solidFill>
-                  <a:srgbClr val="2B2C30"/>
-                </a:solidFill>
-                <a:latin typeface="Courier New"/>
-              </a:rPr>
-              <a:t>                         |</a:t>
-            </a:r>
-          </a:p>
-          <a:p>
-            <a:pPr algn="l">
-              <a:lnSpc>
-                <a:spcPct val="118000"/>
-              </a:lnSpc>
-            </a:pPr>
-            <a:r>
-              <a:rPr sz="971" b="0" i="0">
-                <a:solidFill>
-                  <a:srgbClr val="2B2C30"/>
-                </a:solidFill>
-                <a:latin typeface="Courier New"/>
-              </a:rPr>
-              <a:t>                         v</a:t>
-            </a:r>
-          </a:p>
-          <a:p>
-            <a:pPr algn="l">
-              <a:lnSpc>
-                <a:spcPct val="118000"/>
-              </a:lnSpc>
-            </a:pPr>
-            <a:r>
-              <a:rPr sz="971" b="0" i="0">
-                <a:solidFill>
-                  <a:srgbClr val="2B2C30"/>
-                </a:solidFill>
-                <a:latin typeface="Courier New"/>
-              </a:rPr>
-              <a:t>  +--------------------------------------+</a:t>
-            </a:r>
-          </a:p>
-          <a:p>
-            <a:pPr algn="l">
-              <a:lnSpc>
-                <a:spcPct val="118000"/>
-              </a:lnSpc>
-            </a:pPr>
-            <a:r>
-              <a:rPr sz="971" b="0" i="0">
-                <a:solidFill>
-                  <a:srgbClr val="2B2C30"/>
-                </a:solidFill>
-                <a:latin typeface="Courier New"/>
-              </a:rPr>
-              <a:t>  |  STAGE 1  -  SCORING                 |   "analytical scoring</a:t>
-            </a:r>
-          </a:p>
-          <a:p>
-            <a:pPr algn="l">
-              <a:lnSpc>
-                <a:spcPct val="118000"/>
-              </a:lnSpc>
-            </a:pPr>
-            <a:r>
-              <a:rPr sz="971" b="0" i="0">
-                <a:solidFill>
-                  <a:srgbClr val="2B2C30"/>
-                </a:solidFill>
-                <a:latin typeface="Courier New"/>
-              </a:rPr>
-              <a:t>  |    per rubric criterion:             |    only, no student-</a:t>
-            </a:r>
-          </a:p>
-          <a:p>
-            <a:pPr algn="l">
-              <a:lnSpc>
-                <a:spcPct val="118000"/>
-              </a:lnSpc>
-            </a:pPr>
-            <a:r>
-              <a:rPr sz="971" b="0" i="0">
-                <a:solidFill>
-                  <a:srgbClr val="2B2C30"/>
-                </a:solidFill>
-                <a:latin typeface="Courier New"/>
-              </a:rPr>
-              <a:t>  |      score / max_score               |    facing prose here"</a:t>
-            </a:r>
-          </a:p>
-          <a:p>
-            <a:pPr algn="l">
-              <a:lnSpc>
-                <a:spcPct val="118000"/>
-              </a:lnSpc>
-            </a:pPr>
-            <a:r>
-              <a:rPr sz="971" b="0" i="0">
-                <a:solidFill>
-                  <a:srgbClr val="2B2C30"/>
-                </a:solidFill>
-                <a:latin typeface="Courier New"/>
-              </a:rPr>
-              <a:t>  |      success_evidence[]              |</a:t>
-            </a:r>
-          </a:p>
-          <a:p>
-            <a:pPr algn="l">
-              <a:lnSpc>
-                <a:spcPct val="118000"/>
-              </a:lnSpc>
-            </a:pPr>
-            <a:r>
-              <a:rPr sz="971" b="0" i="0">
-                <a:solidFill>
-                  <a:srgbClr val="2B2C30"/>
-                </a:solidFill>
-                <a:latin typeface="Courier New"/>
-              </a:rPr>
-              <a:t>  |      non_penalized_observations[]    |</a:t>
-            </a:r>
-          </a:p>
-          <a:p>
-            <a:pPr algn="l">
-              <a:lnSpc>
-                <a:spcPct val="118000"/>
-              </a:lnSpc>
-            </a:pPr>
-            <a:r>
-              <a:rPr sz="971" b="0" i="0">
-                <a:solidFill>
-                  <a:srgbClr val="2B2C30"/>
-                </a:solidFill>
-                <a:latin typeface="Courier New"/>
-              </a:rPr>
-              <a:t>  |      deductions[]                    |</a:t>
-            </a:r>
-          </a:p>
-          <a:p>
-            <a:pPr algn="l">
-              <a:lnSpc>
-                <a:spcPct val="118000"/>
-              </a:lnSpc>
-            </a:pPr>
-            <a:r>
-              <a:rPr sz="971" b="0" i="0">
-                <a:solidFill>
-                  <a:srgbClr val="2B2C30"/>
-                </a:solidFill>
-                <a:latin typeface="Courier New"/>
-              </a:rPr>
-              <a:t>  |        points_lost, severity,        |</a:t>
-            </a:r>
-          </a:p>
-          <a:p>
-            <a:pPr algn="l">
-              <a:lnSpc>
-                <a:spcPct val="118000"/>
-              </a:lnSpc>
-            </a:pPr>
-            <a:r>
-              <a:rPr sz="971" b="0" i="0">
-                <a:solidFill>
-                  <a:srgbClr val="2B2C30"/>
-                </a:solidFill>
-                <a:latin typeface="Courier New"/>
-              </a:rPr>
-              <a:t>  |        confidence, rubric_anchor,    |</a:t>
-            </a:r>
-          </a:p>
-          <a:p>
-            <a:pPr algn="l">
-              <a:lnSpc>
-                <a:spcPct val="118000"/>
-              </a:lnSpc>
-            </a:pPr>
-            <a:r>
-              <a:rPr sz="971" b="0" i="0">
-                <a:solidFill>
-                  <a:srgbClr val="2B2C30"/>
-                </a:solidFill>
-                <a:latin typeface="Courier New"/>
-              </a:rPr>
-              <a:t>  |        problem, consequence,         |</a:t>
-            </a:r>
-          </a:p>
-          <a:p>
-            <a:pPr algn="l">
-              <a:lnSpc>
-                <a:spcPct val="118000"/>
-              </a:lnSpc>
-            </a:pPr>
-            <a:r>
-              <a:rPr sz="971" b="0" i="0">
-                <a:solidFill>
-                  <a:srgbClr val="2B2C30"/>
-                </a:solidFill>
-                <a:latin typeface="Courier New"/>
-              </a:rPr>
-              <a:t>  |        how_to_fix, evidence_refs     |</a:t>
-            </a:r>
-          </a:p>
-          <a:p>
-            <a:pPr algn="l">
-              <a:lnSpc>
-                <a:spcPct val="118000"/>
-              </a:lnSpc>
-            </a:pPr>
-            <a:r>
-              <a:rPr sz="971" b="0" i="0">
-                <a:solidFill>
-                  <a:srgbClr val="2B2C30"/>
-                </a:solidFill>
-                <a:latin typeface="Courier New"/>
-              </a:rPr>
-              <a:t>  |    reviewer_audit                    |</a:t>
-            </a:r>
-          </a:p>
-          <a:p>
-            <a:pPr algn="l">
-              <a:lnSpc>
-                <a:spcPct val="118000"/>
-              </a:lnSpc>
-            </a:pPr>
-            <a:r>
-              <a:rPr sz="971" b="0" i="0">
-                <a:solidFill>
-                  <a:srgbClr val="2B2C30"/>
-                </a:solidFill>
-                <a:latin typeface="Courier New"/>
-              </a:rPr>
-              <a:t>  +--------------------------------------+</a:t>
-            </a:r>
-          </a:p>
-          <a:p>
-            <a:pPr algn="l">
-              <a:lnSpc>
-                <a:spcPct val="118000"/>
-              </a:lnSpc>
-            </a:pPr>
-            <a:r>
-              <a:rPr sz="971" b="0" i="0">
-                <a:solidFill>
-                  <a:srgbClr val="2B2C30"/>
-                </a:solidFill>
-                <a:latin typeface="Courier New"/>
-              </a:rPr>
-              <a:t>                         |  validated JSON</a:t>
-            </a:r>
-          </a:p>
-          <a:p>
-            <a:pPr algn="l">
-              <a:lnSpc>
-                <a:spcPct val="118000"/>
-              </a:lnSpc>
-            </a:pPr>
-            <a:r>
-              <a:rPr sz="971" b="0" i="0">
-                <a:solidFill>
-                  <a:srgbClr val="2B2C30"/>
-                </a:solidFill>
-                <a:latin typeface="Courier New"/>
-              </a:rPr>
-              <a:t>                         v</a:t>
-            </a:r>
-          </a:p>
-          <a:p>
-            <a:pPr algn="l">
-              <a:lnSpc>
-                <a:spcPct val="118000"/>
-              </a:lnSpc>
-            </a:pPr>
-            <a:r>
-              <a:rPr sz="971" b="0" i="0">
-                <a:solidFill>
-                  <a:srgbClr val="2B2C30"/>
-                </a:solidFill>
-                <a:latin typeface="Courier New"/>
-              </a:rPr>
-              <a:t>  +--------------------------------------+</a:t>
-            </a:r>
-          </a:p>
-          <a:p>
-            <a:pPr algn="l">
-              <a:lnSpc>
-                <a:spcPct val="118000"/>
-              </a:lnSpc>
-            </a:pPr>
-            <a:r>
-              <a:rPr sz="971" b="0" i="0">
-                <a:solidFill>
-                  <a:srgbClr val="2B2C30"/>
-                </a:solidFill>
-                <a:latin typeface="Courier New"/>
-              </a:rPr>
-              <a:t>  |  STAGE 2  -  FEEDBACK                |   "do not re-grade and</a:t>
-            </a:r>
-          </a:p>
-          <a:p>
-            <a:pPr algn="l">
-              <a:lnSpc>
-                <a:spcPct val="118000"/>
-              </a:lnSpc>
-            </a:pPr>
-            <a:r>
-              <a:rPr sz="971" b="0" i="0">
-                <a:solidFill>
-                  <a:srgbClr val="2B2C30"/>
-                </a:solidFill>
-                <a:latin typeface="Courier New"/>
-              </a:rPr>
-              <a:t>  |    at most 6 high-confidence items   |    do not look for new</a:t>
-            </a:r>
-          </a:p>
-          <a:p>
-            <a:pPr algn="l">
-              <a:lnSpc>
-                <a:spcPct val="118000"/>
-              </a:lnSpc>
-            </a:pPr>
-            <a:r>
-              <a:rPr sz="971" b="0" i="0">
-                <a:solidFill>
-                  <a:srgbClr val="2B2C30"/>
-                </a:solidFill>
-                <a:latin typeface="Courier New"/>
-              </a:rPr>
-              <a:t>  |    student_feedback + reviewer_notes |    defects"</a:t>
-            </a:r>
-          </a:p>
-          <a:p>
-            <a:pPr algn="l">
-              <a:lnSpc>
-                <a:spcPct val="118000"/>
-              </a:lnSpc>
-            </a:pPr>
-            <a:r>
-              <a:rPr sz="971" b="0" i="0">
-                <a:solidFill>
-                  <a:srgbClr val="2B2C30"/>
-                </a:solidFill>
-                <a:latin typeface="Courier New"/>
-              </a:rPr>
-              <a:t>  +--------------------------------------+</a:t>
-            </a:r>
-          </a:p>
-          <a:p>
-            <a:pPr algn="l">
-              <a:lnSpc>
-                <a:spcPct val="118000"/>
-              </a:lnSpc>
-            </a:pPr>
-            <a:r>
-              <a:rPr sz="971" b="0" i="0">
+              <a:rPr sz="1600" b="0" i="0">
+                <a:solidFill>
+                  <a:srgbClr val="2B2C30"/>
+                </a:solidFill>
+                <a:latin typeface="Courier New"/>
+              </a:rPr>
+              <a:t>.</a:t>
+            </a:r>
+          </a:p>
+          <a:p>
+            <a:pPr algn="l">
+              <a:lnSpc>
+                <a:spcPct val="118000"/>
+              </a:lnSpc>
+            </a:pPr>
+            <a:r>
+              <a:rPr sz="1600" b="0" i="0">
+                <a:solidFill>
+                  <a:srgbClr val="2B2C30"/>
+                </a:solidFill>
+                <a:latin typeface="Courier New"/>
+              </a:rPr>
+              <a:t>|-- src/prompt/            8 files     the grading protocol itself</a:t>
+            </a:r>
+          </a:p>
+          <a:p>
+            <a:pPr algn="l">
+              <a:lnSpc>
+                <a:spcPct val="118000"/>
+              </a:lnSpc>
+            </a:pPr>
+            <a:r>
+              <a:rPr sz="1600" b="0" i="0">
+                <a:solidFill>
+                  <a:srgbClr val="2B2C30"/>
+                </a:solidFill>
+                <a:latin typeface="Courier New"/>
+              </a:rPr>
+              <a:t>|-- src/pipeline/         18 scripts   render, run, validate, analyse</a:t>
+            </a:r>
+          </a:p>
+          <a:p>
+            <a:pPr algn="l">
+              <a:lnSpc>
+                <a:spcPct val="118000"/>
+              </a:lnSpc>
+            </a:pPr>
+            <a:r>
+              <a:rPr sz="1600" b="0" i="0">
+                <a:solidFill>
+                  <a:srgbClr val="2B2C30"/>
+                </a:solidFill>
+                <a:latin typeface="Courier New"/>
+              </a:rPr>
+              <a:t>|-- src/workflows/         5 scripts   stage orchestration</a:t>
+            </a:r>
+          </a:p>
+          <a:p>
+            <a:pPr algn="l">
+              <a:lnSpc>
+                <a:spcPct val="118000"/>
+              </a:lnSpc>
+            </a:pPr>
+            <a:r>
+              <a:rPr sz="1600" b="0" i="0">
+                <a:solidFill>
+                  <a:srgbClr val="2B2C30"/>
+                </a:solidFill>
+                <a:latin typeface="Courier New"/>
+              </a:rPr>
+              <a:t>|-- src/reproduce.py       1 command   the whole paper, no API keys</a:t>
+            </a:r>
+          </a:p>
+          <a:p>
+            <a:pPr algn="l">
+              <a:lnSpc>
+                <a:spcPct val="118000"/>
+              </a:lnSpc>
+            </a:pPr>
+            <a:r>
+              <a:rPr sz="1600" b="0" i="0">
+                <a:solidFill>
+                  <a:srgbClr val="2B2C30"/>
+                </a:solidFill>
+                <a:latin typeface="Courier New"/>
+              </a:rPr>
+              <a:t>|-- data/lab03-filmnow/</a:t>
+            </a:r>
+          </a:p>
+          <a:p>
+            <a:pPr algn="l">
+              <a:lnSpc>
+                <a:spcPct val="118000"/>
+              </a:lnSpc>
+            </a:pPr>
+            <a:r>
+              <a:rPr sz="1600" b="0" i="0">
+                <a:solidFill>
+                  <a:srgbClr val="2B2C30"/>
+                </a:solidFill>
+                <a:latin typeface="Courier New"/>
+              </a:rPr>
+              <a:t>|   |-- runs/              6 runs      2 models x 3 repetitions</a:t>
+            </a:r>
+          </a:p>
+          <a:p>
+            <a:pPr algn="l">
+              <a:lnSpc>
+                <a:spcPct val="118000"/>
+              </a:lnSpc>
+            </a:pPr>
+            <a:r>
+              <a:rPr sz="1600" b="0" i="0">
+                <a:solidFill>
+                  <a:srgbClr val="2B2C30"/>
+                </a:solidFill>
+                <a:latin typeface="Courier New"/>
+              </a:rPr>
+              <a:t>|   |     inputs/          84 anonymized Java submissions + rubric</a:t>
+            </a:r>
+          </a:p>
+          <a:p>
+            <a:pPr algn="l">
+              <a:lnSpc>
+                <a:spcPct val="118000"/>
+              </a:lnSpc>
+            </a:pPr>
+            <a:r>
+              <a:rPr sz="1600" b="0" i="0">
+                <a:solidFill>
+                  <a:srgbClr val="2B2C30"/>
+                </a:solidFill>
+                <a:latin typeface="Courier New"/>
+              </a:rPr>
+              <a:t>|   |     prompts/         1008 rendered prompts, the exact bytes sent</a:t>
+            </a:r>
+          </a:p>
+          <a:p>
+            <a:pPr algn="l">
+              <a:lnSpc>
+                <a:spcPct val="118000"/>
+              </a:lnSpc>
+            </a:pPr>
+            <a:r>
+              <a:rPr sz="1600" b="0" i="0">
+                <a:solidFill>
+                  <a:srgbClr val="2B2C30"/>
+                </a:solidFill>
+                <a:latin typeface="Courier New"/>
+              </a:rPr>
+              <a:t>|   |     outputs/         504 LLM assessments + TA + expert reference</a:t>
+            </a:r>
+          </a:p>
+          <a:p>
+            <a:pPr algn="l">
+              <a:lnSpc>
+                <a:spcPct val="118000"/>
+              </a:lnSpc>
+            </a:pPr>
+            <a:r>
+              <a:rPr sz="1600" b="0" i="0">
+                <a:solidFill>
+                  <a:srgbClr val="2B2C30"/>
+                </a:solidFill>
+                <a:latin typeface="Courier New"/>
+              </a:rPr>
+              <a:t>|   |     analyses/        per-run metrics + semantic-match caches</a:t>
+            </a:r>
+          </a:p>
+          <a:p>
+            <a:pPr algn="l">
+              <a:lnSpc>
+                <a:spcPct val="118000"/>
+              </a:lnSpc>
+            </a:pPr>
+            <a:r>
+              <a:rPr sz="1600" b="0" i="0">
+                <a:solidFill>
+                  <a:srgbClr val="2B2C30"/>
+                </a:solidFill>
+                <a:latin typeface="Courier New"/>
+              </a:rPr>
+              <a:t>|   |-- results/           benchmark, stability, by_category</a:t>
+            </a:r>
+          </a:p>
+          <a:p>
+            <a:pPr algn="l">
+              <a:lnSpc>
+                <a:spcPct val="118000"/>
+              </a:lnSpc>
+            </a:pPr>
+            <a:r>
+              <a:rPr sz="1600" b="0" i="0">
+                <a:solidFill>
+                  <a:srgbClr val="2B2C30"/>
+                </a:solidFill>
+                <a:latin typeface="Courier New"/>
+              </a:rPr>
+              <a:t>|   `-- study/             three-run manifests</a:t>
+            </a:r>
+          </a:p>
+          <a:p>
+            <a:pPr algn="l">
+              <a:lnSpc>
+                <a:spcPct val="118000"/>
+              </a:lnSpc>
+            </a:pPr>
+            <a:r>
+              <a:rPr sz="1600" b="0" i="0">
+                <a:solidFill>
+                  <a:srgbClr val="2B2C30"/>
+                </a:solidFill>
+                <a:latin typeface="Courier New"/>
+              </a:rPr>
+              <a:t>`-- docs/                  paper PDF, 13 figures, 13 tables, 3 TikZ</a:t>
+            </a:r>
+          </a:p>
+          <a:p>
+            <a:pPr algn="l">
+              <a:lnSpc>
+                <a:spcPct val="118000"/>
+              </a:lnSpc>
+            </a:pPr>
+            <a:r>
+              <a:rPr sz="1600" b="0" i="0">
                 <a:solidFill>
                   <a:srgbClr val="2B2C30"/>
                 </a:solidFill>
@@ -6947,13 +6847,13 @@
               </a:lnSpc>
             </a:pPr>
             <a:r>
-              <a:rPr sz="971" b="0" i="0">
-                <a:solidFill>
-                  <a:srgbClr val="2B2C30"/>
-                </a:solidFill>
-                <a:latin typeface="Courier New"/>
-              </a:rPr>
-              <a:t>prompt_version v13-two-stage  .  temperature 0  .  high reasoning effort</a:t>
+              <a:rPr sz="1600" b="0" i="0">
+                <a:solidFill>
+                  <a:srgbClr val="2B2C30"/>
+                </a:solidFill>
+                <a:latin typeface="Courier New"/>
+              </a:rPr>
+              <a:t>~10k lines of Python  .  132 MB of data  .  all of it regenerable</a:t>
             </a:r>
           </a:p>
         </p:txBody>
@@ -7048,7 +6948,7 @@
                 </a:solidFill>
                 <a:latin typeface="Public Sans"/>
               </a:rPr>
-              <a:t>THE PROMPT (2/3): DYNAMIC INJECTION</a:t>
+              <a:t>THE PROMPT (1/3): TWO STAGES, ON PURPOSE</a:t>
             </a:r>
           </a:p>
         </p:txBody>
@@ -7122,7 +7022,7 @@
                 </a:solidFill>
                 <a:latin typeface="Courier New"/>
               </a:rPr>
-              <a:t>Nothing in src/prompt/ is a finished prompt. Every file is a template</a:t>
+              <a:t>  assignment spec + official grading reference + starter scaffold</a:t>
             </a:r>
           </a:p>
           <a:p>
@@ -7138,7 +7038,7 @@
                 </a:solidFill>
                 <a:latin typeface="Courier New"/>
               </a:rPr>
-              <a:t>with {{PLACEHOLDER}} slots, filled at two distinct moments.</a:t>
+              <a:t>  + rubric.json + course principles + calibration examples</a:t>
             </a:r>
           </a:p>
           <a:p>
@@ -7154,6 +7054,374 @@
                 </a:solidFill>
                 <a:latin typeface="Courier New"/>
               </a:rPr>
+              <a:t>  + anonymized submission package</a:t>
+            </a:r>
+          </a:p>
+          <a:p>
+            <a:pPr algn="l">
+              <a:lnSpc>
+                <a:spcPct val="118000"/>
+              </a:lnSpc>
+            </a:pPr>
+            <a:r>
+              <a:rPr sz="971" b="0" i="0">
+                <a:solidFill>
+                  <a:srgbClr val="2B2C30"/>
+                </a:solidFill>
+                <a:latin typeface="Courier New"/>
+              </a:rPr>
+              <a:t>                         |</a:t>
+            </a:r>
+          </a:p>
+          <a:p>
+            <a:pPr algn="l">
+              <a:lnSpc>
+                <a:spcPct val="118000"/>
+              </a:lnSpc>
+            </a:pPr>
+            <a:r>
+              <a:rPr sz="971" b="0" i="0">
+                <a:solidFill>
+                  <a:srgbClr val="2B2C30"/>
+                </a:solidFill>
+                <a:latin typeface="Courier New"/>
+              </a:rPr>
+              <a:t>                         v</a:t>
+            </a:r>
+          </a:p>
+          <a:p>
+            <a:pPr algn="l">
+              <a:lnSpc>
+                <a:spcPct val="118000"/>
+              </a:lnSpc>
+            </a:pPr>
+            <a:r>
+              <a:rPr sz="971" b="0" i="0">
+                <a:solidFill>
+                  <a:srgbClr val="2B2C30"/>
+                </a:solidFill>
+                <a:latin typeface="Courier New"/>
+              </a:rPr>
+              <a:t>  +--------------------------------------+</a:t>
+            </a:r>
+          </a:p>
+          <a:p>
+            <a:pPr algn="l">
+              <a:lnSpc>
+                <a:spcPct val="118000"/>
+              </a:lnSpc>
+            </a:pPr>
+            <a:r>
+              <a:rPr sz="971" b="0" i="0">
+                <a:solidFill>
+                  <a:srgbClr val="2B2C30"/>
+                </a:solidFill>
+                <a:latin typeface="Courier New"/>
+              </a:rPr>
+              <a:t>  |  STAGE 1  -  SCORING                 |   "analytical scoring</a:t>
+            </a:r>
+          </a:p>
+          <a:p>
+            <a:pPr algn="l">
+              <a:lnSpc>
+                <a:spcPct val="118000"/>
+              </a:lnSpc>
+            </a:pPr>
+            <a:r>
+              <a:rPr sz="971" b="0" i="0">
+                <a:solidFill>
+                  <a:srgbClr val="2B2C30"/>
+                </a:solidFill>
+                <a:latin typeface="Courier New"/>
+              </a:rPr>
+              <a:t>  |    per rubric criterion:             |    only, no student-</a:t>
+            </a:r>
+          </a:p>
+          <a:p>
+            <a:pPr algn="l">
+              <a:lnSpc>
+                <a:spcPct val="118000"/>
+              </a:lnSpc>
+            </a:pPr>
+            <a:r>
+              <a:rPr sz="971" b="0" i="0">
+                <a:solidFill>
+                  <a:srgbClr val="2B2C30"/>
+                </a:solidFill>
+                <a:latin typeface="Courier New"/>
+              </a:rPr>
+              <a:t>  |      score / max_score               |    facing prose here"</a:t>
+            </a:r>
+          </a:p>
+          <a:p>
+            <a:pPr algn="l">
+              <a:lnSpc>
+                <a:spcPct val="118000"/>
+              </a:lnSpc>
+            </a:pPr>
+            <a:r>
+              <a:rPr sz="971" b="0" i="0">
+                <a:solidFill>
+                  <a:srgbClr val="2B2C30"/>
+                </a:solidFill>
+                <a:latin typeface="Courier New"/>
+              </a:rPr>
+              <a:t>  |      success_evidence[]              |</a:t>
+            </a:r>
+          </a:p>
+          <a:p>
+            <a:pPr algn="l">
+              <a:lnSpc>
+                <a:spcPct val="118000"/>
+              </a:lnSpc>
+            </a:pPr>
+            <a:r>
+              <a:rPr sz="971" b="0" i="0">
+                <a:solidFill>
+                  <a:srgbClr val="2B2C30"/>
+                </a:solidFill>
+                <a:latin typeface="Courier New"/>
+              </a:rPr>
+              <a:t>  |      non_penalized_observations[]    |</a:t>
+            </a:r>
+          </a:p>
+          <a:p>
+            <a:pPr algn="l">
+              <a:lnSpc>
+                <a:spcPct val="118000"/>
+              </a:lnSpc>
+            </a:pPr>
+            <a:r>
+              <a:rPr sz="971" b="0" i="0">
+                <a:solidFill>
+                  <a:srgbClr val="2B2C30"/>
+                </a:solidFill>
+                <a:latin typeface="Courier New"/>
+              </a:rPr>
+              <a:t>  |      deductions[]                    |</a:t>
+            </a:r>
+          </a:p>
+          <a:p>
+            <a:pPr algn="l">
+              <a:lnSpc>
+                <a:spcPct val="118000"/>
+              </a:lnSpc>
+            </a:pPr>
+            <a:r>
+              <a:rPr sz="971" b="0" i="0">
+                <a:solidFill>
+                  <a:srgbClr val="2B2C30"/>
+                </a:solidFill>
+                <a:latin typeface="Courier New"/>
+              </a:rPr>
+              <a:t>  |        points_lost, severity,        |</a:t>
+            </a:r>
+          </a:p>
+          <a:p>
+            <a:pPr algn="l">
+              <a:lnSpc>
+                <a:spcPct val="118000"/>
+              </a:lnSpc>
+            </a:pPr>
+            <a:r>
+              <a:rPr sz="971" b="0" i="0">
+                <a:solidFill>
+                  <a:srgbClr val="2B2C30"/>
+                </a:solidFill>
+                <a:latin typeface="Courier New"/>
+              </a:rPr>
+              <a:t>  |        confidence, rubric_anchor,    |</a:t>
+            </a:r>
+          </a:p>
+          <a:p>
+            <a:pPr algn="l">
+              <a:lnSpc>
+                <a:spcPct val="118000"/>
+              </a:lnSpc>
+            </a:pPr>
+            <a:r>
+              <a:rPr sz="971" b="0" i="0">
+                <a:solidFill>
+                  <a:srgbClr val="2B2C30"/>
+                </a:solidFill>
+                <a:latin typeface="Courier New"/>
+              </a:rPr>
+              <a:t>  |        problem, consequence,         |</a:t>
+            </a:r>
+          </a:p>
+          <a:p>
+            <a:pPr algn="l">
+              <a:lnSpc>
+                <a:spcPct val="118000"/>
+              </a:lnSpc>
+            </a:pPr>
+            <a:r>
+              <a:rPr sz="971" b="0" i="0">
+                <a:solidFill>
+                  <a:srgbClr val="2B2C30"/>
+                </a:solidFill>
+                <a:latin typeface="Courier New"/>
+              </a:rPr>
+              <a:t>  |        how_to_fix, evidence_refs     |</a:t>
+            </a:r>
+          </a:p>
+          <a:p>
+            <a:pPr algn="l">
+              <a:lnSpc>
+                <a:spcPct val="118000"/>
+              </a:lnSpc>
+            </a:pPr>
+            <a:r>
+              <a:rPr sz="971" b="0" i="0">
+                <a:solidFill>
+                  <a:srgbClr val="2B2C30"/>
+                </a:solidFill>
+                <a:latin typeface="Courier New"/>
+              </a:rPr>
+              <a:t>  |    reviewer_audit                    |</a:t>
+            </a:r>
+          </a:p>
+          <a:p>
+            <a:pPr algn="l">
+              <a:lnSpc>
+                <a:spcPct val="118000"/>
+              </a:lnSpc>
+            </a:pPr>
+            <a:r>
+              <a:rPr sz="971" b="0" i="0">
+                <a:solidFill>
+                  <a:srgbClr val="2B2C30"/>
+                </a:solidFill>
+                <a:latin typeface="Courier New"/>
+              </a:rPr>
+              <a:t>  +--------------------------------------+</a:t>
+            </a:r>
+          </a:p>
+          <a:p>
+            <a:pPr algn="l">
+              <a:lnSpc>
+                <a:spcPct val="118000"/>
+              </a:lnSpc>
+            </a:pPr>
+            <a:r>
+              <a:rPr sz="971" b="0" i="0">
+                <a:solidFill>
+                  <a:srgbClr val="2B2C30"/>
+                </a:solidFill>
+                <a:latin typeface="Courier New"/>
+              </a:rPr>
+              <a:t>                         |  validated JSON</a:t>
+            </a:r>
+          </a:p>
+          <a:p>
+            <a:pPr algn="l">
+              <a:lnSpc>
+                <a:spcPct val="118000"/>
+              </a:lnSpc>
+            </a:pPr>
+            <a:r>
+              <a:rPr sz="971" b="0" i="0">
+                <a:solidFill>
+                  <a:srgbClr val="2B2C30"/>
+                </a:solidFill>
+                <a:latin typeface="Courier New"/>
+              </a:rPr>
+              <a:t>                         v</a:t>
+            </a:r>
+          </a:p>
+          <a:p>
+            <a:pPr algn="l">
+              <a:lnSpc>
+                <a:spcPct val="118000"/>
+              </a:lnSpc>
+            </a:pPr>
+            <a:r>
+              <a:rPr sz="971" b="0" i="0">
+                <a:solidFill>
+                  <a:srgbClr val="2B2C30"/>
+                </a:solidFill>
+                <a:latin typeface="Courier New"/>
+              </a:rPr>
+              <a:t>  +--------------------------------------+</a:t>
+            </a:r>
+          </a:p>
+          <a:p>
+            <a:pPr algn="l">
+              <a:lnSpc>
+                <a:spcPct val="118000"/>
+              </a:lnSpc>
+            </a:pPr>
+            <a:r>
+              <a:rPr sz="971" b="0" i="0">
+                <a:solidFill>
+                  <a:srgbClr val="2B2C30"/>
+                </a:solidFill>
+                <a:latin typeface="Courier New"/>
+              </a:rPr>
+              <a:t>  |  STAGE 2  -  FEEDBACK                |   "do not re-grade and</a:t>
+            </a:r>
+          </a:p>
+          <a:p>
+            <a:pPr algn="l">
+              <a:lnSpc>
+                <a:spcPct val="118000"/>
+              </a:lnSpc>
+            </a:pPr>
+            <a:r>
+              <a:rPr sz="971" b="0" i="0">
+                <a:solidFill>
+                  <a:srgbClr val="2B2C30"/>
+                </a:solidFill>
+                <a:latin typeface="Courier New"/>
+              </a:rPr>
+              <a:t>  |    at most 6 high-confidence items   |    do not look for new</a:t>
+            </a:r>
+          </a:p>
+          <a:p>
+            <a:pPr algn="l">
+              <a:lnSpc>
+                <a:spcPct val="118000"/>
+              </a:lnSpc>
+            </a:pPr>
+            <a:r>
+              <a:rPr sz="971" b="0" i="0">
+                <a:solidFill>
+                  <a:srgbClr val="2B2C30"/>
+                </a:solidFill>
+                <a:latin typeface="Courier New"/>
+              </a:rPr>
+              <a:t>  |    student_feedback + reviewer_notes |    defects"</a:t>
+            </a:r>
+          </a:p>
+          <a:p>
+            <a:pPr algn="l">
+              <a:lnSpc>
+                <a:spcPct val="118000"/>
+              </a:lnSpc>
+            </a:pPr>
+            <a:r>
+              <a:rPr sz="971" b="0" i="0">
+                <a:solidFill>
+                  <a:srgbClr val="2B2C30"/>
+                </a:solidFill>
+                <a:latin typeface="Courier New"/>
+              </a:rPr>
+              <a:t>  +--------------------------------------+</a:t>
+            </a:r>
+          </a:p>
+          <a:p>
+            <a:pPr algn="l">
+              <a:lnSpc>
+                <a:spcPct val="118000"/>
+              </a:lnSpc>
+            </a:pPr>
+            <a:r>
+              <a:rPr sz="971" b="0" i="0">
+                <a:solidFill>
+                  <a:srgbClr val="2B2C30"/>
+                </a:solidFill>
+                <a:latin typeface="Courier New"/>
+              </a:rPr>
               <a:t/>
             </a:r>
           </a:p>
@@ -7170,375 +7438,7 @@
                 </a:solidFill>
                 <a:latin typeface="Courier New"/>
               </a:rPr>
-              <a:t>BUILD TIME  --  src/pipeline/02_render_prompts.py</a:t>
-            </a:r>
-          </a:p>
-          <a:p>
-            <a:pPr algn="l">
-              <a:lnSpc>
-                <a:spcPct val="118000"/>
-              </a:lnSpc>
-            </a:pPr>
-            <a:r>
-              <a:rPr sz="971" b="0" i="0">
-                <a:solidFill>
-                  <a:srgbClr val="2B2C30"/>
-                </a:solidFill>
-                <a:latin typeface="Courier New"/>
-              </a:rPr>
-              <a:t>  {{EXPERIMENT_METADATA}}       per-submission JSON: id, role,</a:t>
-            </a:r>
-          </a:p>
-          <a:p>
-            <a:pPr algn="l">
-              <a:lnSpc>
-                <a:spcPct val="118000"/>
-              </a:lnSpc>
-            </a:pPr>
-            <a:r>
-              <a:rPr sz="971" b="0" i="0">
-                <a:solidFill>
-                  <a:srgbClr val="2B2C30"/>
-                </a:solidFill>
-                <a:latin typeface="Courier New"/>
-              </a:rPr>
-              <a:t>                                provider, model, temperature,</a:t>
-            </a:r>
-          </a:p>
-          <a:p>
-            <a:pPr algn="l">
-              <a:lnSpc>
-                <a:spcPct val="118000"/>
-              </a:lnSpc>
-            </a:pPr>
-            <a:r>
-              <a:rPr sz="971" b="0" i="0">
-                <a:solidFill>
-                  <a:srgbClr val="2B2C30"/>
-                </a:solidFill>
-                <a:latin typeface="Courier New"/>
-              </a:rPr>
-              <a:t>                                reasoning_effort, prompt_version</a:t>
-            </a:r>
-          </a:p>
-          <a:p>
-            <a:pPr algn="l">
-              <a:lnSpc>
-                <a:spcPct val="118000"/>
-              </a:lnSpc>
-            </a:pPr>
-            <a:r>
-              <a:rPr sz="971" b="0" i="0">
-                <a:solidFill>
-                  <a:srgbClr val="2B2C30"/>
-                </a:solidFill>
-                <a:latin typeface="Courier New"/>
-              </a:rPr>
-              <a:t>  {{LAB_SPEC_TEXT}}             &lt;- assignment/lab_specification.md</a:t>
-            </a:r>
-          </a:p>
-          <a:p>
-            <a:pPr algn="l">
-              <a:lnSpc>
-                <a:spcPct val="118000"/>
-              </a:lnSpc>
-            </a:pPr>
-            <a:r>
-              <a:rPr sz="971" b="0" i="0">
-                <a:solidFill>
-                  <a:srgbClr val="2B2C30"/>
-                </a:solidFill>
-                <a:latin typeface="Courier New"/>
-              </a:rPr>
-              <a:t>  {{GRADING_SHEET_TEXT}}        &lt;- assignment/grading_reference.md</a:t>
-            </a:r>
-          </a:p>
-          <a:p>
-            <a:pPr algn="l">
-              <a:lnSpc>
-                <a:spcPct val="118000"/>
-              </a:lnSpc>
-            </a:pPr>
-            <a:r>
-              <a:rPr sz="971" b="0" i="0">
-                <a:solidFill>
-                  <a:srgbClr val="2B2C30"/>
-                </a:solidFill>
-                <a:latin typeface="Courier New"/>
-              </a:rPr>
-              <a:t>  {{STARTER_SCAFFOLD_TEXT}}     &lt;- assignment/starter_scaffold.md</a:t>
-            </a:r>
-          </a:p>
-          <a:p>
-            <a:pPr algn="l">
-              <a:lnSpc>
-                <a:spcPct val="118000"/>
-              </a:lnSpc>
-            </a:pPr>
-            <a:r>
-              <a:rPr sz="971" b="0" i="0">
-                <a:solidFill>
-                  <a:srgbClr val="2B2C30"/>
-                </a:solidFill>
-                <a:latin typeface="Courier New"/>
-              </a:rPr>
-              <a:t>  {{RUBRIC_JSON}}               &lt;- rubric.json, gated rubric_ready</a:t>
-            </a:r>
-          </a:p>
-          <a:p>
-            <a:pPr algn="l">
-              <a:lnSpc>
-                <a:spcPct val="118000"/>
-              </a:lnSpc>
-            </a:pPr>
-            <a:r>
-              <a:rPr sz="971" b="0" i="0">
-                <a:solidFill>
-                  <a:srgbClr val="2B2C30"/>
-                </a:solidFill>
-                <a:latin typeface="Courier New"/>
-              </a:rPr>
-              <a:t>  {{CORE_EVALUATION_TEXT}}      &lt;- evaluation_principles.md</a:t>
-            </a:r>
-          </a:p>
-          <a:p>
-            <a:pPr algn="l">
-              <a:lnSpc>
-                <a:spcPct val="118000"/>
-              </a:lnSpc>
-            </a:pPr>
-            <a:r>
-              <a:rPr sz="971" b="0" i="0">
-                <a:solidFill>
-                  <a:srgbClr val="2B2C30"/>
-                </a:solidFill>
-                <a:latin typeface="Courier New"/>
-              </a:rPr>
-              <a:t>  {{ABSTRACT_CALIBRATION_TEXT}} &lt;- abstract_calibration.md</a:t>
-            </a:r>
-          </a:p>
-          <a:p>
-            <a:pPr algn="l">
-              <a:lnSpc>
-                <a:spcPct val="118000"/>
-              </a:lnSpc>
-            </a:pPr>
-            <a:r>
-              <a:rPr sz="971" b="0" i="0">
-                <a:solidFill>
-                  <a:srgbClr val="2B2C30"/>
-                </a:solidFill>
-                <a:latin typeface="Courier New"/>
-              </a:rPr>
-              <a:t>  {{COMMENT_STYLE_TEXT}}        &lt;- feedback_style_guide.md  (st.2)</a:t>
-            </a:r>
-          </a:p>
-          <a:p>
-            <a:pPr algn="l">
-              <a:lnSpc>
-                <a:spcPct val="118000"/>
-              </a:lnSpc>
-            </a:pPr>
-            <a:r>
-              <a:rPr sz="971" b="0" i="0">
-                <a:solidFill>
-                  <a:srgbClr val="2B2C30"/>
-                </a:solidFill>
-                <a:latin typeface="Courier New"/>
-              </a:rPr>
-              <a:t>  {{SUBMISSION_PACKAGE}}        &lt;- submissions/S17.md</a:t>
-            </a:r>
-          </a:p>
-          <a:p>
-            <a:pPr algn="l">
-              <a:lnSpc>
-                <a:spcPct val="118000"/>
-              </a:lnSpc>
-            </a:pPr>
-            <a:r>
-              <a:rPr sz="971" b="0" i="0">
-                <a:solidFill>
-                  <a:srgbClr val="2B2C30"/>
-                </a:solidFill>
-                <a:latin typeface="Courier New"/>
-              </a:rPr>
-              <a:t>  {{OUTPUT_SCHEMA_JSON}}        &lt;- schema_stage{1,2}.json</a:t>
-            </a:r>
-          </a:p>
-          <a:p>
-            <a:pPr algn="l">
-              <a:lnSpc>
-                <a:spcPct val="118000"/>
-              </a:lnSpc>
-            </a:pPr>
-            <a:r>
-              <a:rPr sz="971" b="0" i="0">
-                <a:solidFill>
-                  <a:srgbClr val="2B2C30"/>
-                </a:solidFill>
-                <a:latin typeface="Courier New"/>
-              </a:rPr>
-              <a:t/>
-            </a:r>
-          </a:p>
-          <a:p>
-            <a:pPr algn="l">
-              <a:lnSpc>
-                <a:spcPct val="118000"/>
-              </a:lnSpc>
-            </a:pPr>
-            <a:r>
-              <a:rPr sz="971" b="0" i="0">
-                <a:solidFill>
-                  <a:srgbClr val="2B2C30"/>
-                </a:solidFill>
-                <a:latin typeface="Courier New"/>
-              </a:rPr>
-              <a:t>RUN TIME  --  src/pipeline/utils/llm_execution.py</a:t>
-            </a:r>
-          </a:p>
-          <a:p>
-            <a:pPr algn="l">
-              <a:lnSpc>
-                <a:spcPct val="118000"/>
-              </a:lnSpc>
-            </a:pPr>
-            <a:r>
-              <a:rPr sz="971" b="0" i="0">
-                <a:solidFill>
-                  <a:srgbClr val="2B2C30"/>
-                </a:solidFill>
-                <a:latin typeface="Courier New"/>
-              </a:rPr>
-              <a:t>  {{STAGE1_JSON}}   left UNRESOLVED on disk on purpose, then swapped</a:t>
-            </a:r>
-          </a:p>
-          <a:p>
-            <a:pPr algn="l">
-              <a:lnSpc>
-                <a:spcPct val="118000"/>
-              </a:lnSpc>
-            </a:pPr>
-            <a:r>
-              <a:rPr sz="971" b="0" i="0">
-                <a:solidFill>
-                  <a:srgbClr val="2B2C30"/>
-                </a:solidFill>
-                <a:latin typeface="Courier New"/>
-              </a:rPr>
-              <a:t>                    at call time for the parsed, re-serialized</a:t>
-            </a:r>
-          </a:p>
-          <a:p>
-            <a:pPr algn="l">
-              <a:lnSpc>
-                <a:spcPct val="118000"/>
-              </a:lnSpc>
-            </a:pPr>
-            <a:r>
-              <a:rPr sz="971" b="0" i="0">
-                <a:solidFill>
-                  <a:srgbClr val="2B2C30"/>
-                </a:solidFill>
-                <a:latin typeface="Courier New"/>
-              </a:rPr>
-              <a:t>                    stage 1 response</a:t>
-            </a:r>
-          </a:p>
-          <a:p>
-            <a:pPr algn="l">
-              <a:lnSpc>
-                <a:spcPct val="118000"/>
-              </a:lnSpc>
-            </a:pPr>
-            <a:r>
-              <a:rPr sz="971" b="0" i="0">
-                <a:solidFill>
-                  <a:srgbClr val="2B2C30"/>
-                </a:solidFill>
-                <a:latin typeface="Courier New"/>
-              </a:rPr>
-              <a:t/>
-            </a:r>
-          </a:p>
-          <a:p>
-            <a:pPr algn="l">
-              <a:lnSpc>
-                <a:spcPct val="118000"/>
-              </a:lnSpc>
-            </a:pPr>
-            <a:r>
-              <a:rPr sz="971" b="0" i="0">
-                <a:solidFill>
-                  <a:srgbClr val="2B2C30"/>
-                </a:solidFill>
-                <a:latin typeface="Courier New"/>
-              </a:rPr>
-              <a:t>  stage 1:  9 slots resolved   136-line template  -&gt;  1753 lines</a:t>
-            </a:r>
-          </a:p>
-          <a:p>
-            <a:pPr algn="l">
-              <a:lnSpc>
-                <a:spcPct val="118000"/>
-              </a:lnSpc>
-            </a:pPr>
-            <a:r>
-              <a:rPr sz="971" b="0" i="0">
-                <a:solidFill>
-                  <a:srgbClr val="2B2C30"/>
-                </a:solidFill>
-                <a:latin typeface="Courier New"/>
-              </a:rPr>
-              <a:t>  stage 2:  1 slot left open   grep the shipped file, it is there</a:t>
-            </a:r>
-          </a:p>
-          <a:p>
-            <a:pPr algn="l">
-              <a:lnSpc>
-                <a:spcPct val="118000"/>
-              </a:lnSpc>
-            </a:pPr>
-            <a:r>
-              <a:rPr sz="971" b="0" i="0">
-                <a:solidFill>
-                  <a:srgbClr val="2B2C30"/>
-                </a:solidFill>
-                <a:latin typeface="Courier New"/>
-              </a:rPr>
-              <a:t/>
-            </a:r>
-          </a:p>
-          <a:p>
-            <a:pPr algn="l">
-              <a:lnSpc>
-                <a:spcPct val="118000"/>
-              </a:lnSpc>
-            </a:pPr>
-            <a:r>
-              <a:rPr sz="971" b="0" i="0">
-                <a:solidFill>
-                  <a:srgbClr val="2B2C30"/>
-                </a:solidFill>
-                <a:latin typeface="Courier New"/>
-              </a:rPr>
-              <a:t>So stage 2 never sees raw model prose, only re-parsed JSON - and the</a:t>
-            </a:r>
-          </a:p>
-          <a:p>
-            <a:pPr algn="l">
-              <a:lnSpc>
-                <a:spcPct val="118000"/>
-              </a:lnSpc>
-            </a:pPr>
-            <a:r>
-              <a:rPr sz="971" b="0" i="0">
-                <a:solidFill>
-                  <a:srgbClr val="2B2C30"/>
-                </a:solidFill>
-                <a:latin typeface="Courier New"/>
-              </a:rPr>
-              <a:t>1008 rendered files are the audit trail of what we actually sent.</a:t>
+              <a:t>prompt_version v13-two-stage  .  temperature 0  .  high reasoning effort</a:t>
             </a:r>
           </a:p>
         </p:txBody>
@@ -7633,7 +7533,7 @@
                 </a:solidFill>
                 <a:latin typeface="Public Sans"/>
               </a:rPr>
-              <a:t>THE PROMPT (3/3): THE GUARDRAILS</a:t>
+              <a:t>THE PROMPT (2/3): DYNAMIC INJECTION</a:t>
             </a:r>
           </a:p>
         </p:txBody>
@@ -7701,151 +7601,39 @@
               </a:lnSpc>
             </a:pPr>
             <a:r>
-              <a:rPr sz="1380" b="0" i="0">
-                <a:solidFill>
-                  <a:srgbClr val="2B2C30"/>
-                </a:solidFill>
-                <a:latin typeface="Courier New"/>
-              </a:rPr>
-              <a:t>src/prompt/</a:t>
-            </a:r>
-          </a:p>
-          <a:p>
-            <a:pPr algn="l">
-              <a:lnSpc>
-                <a:spcPct val="118000"/>
-              </a:lnSpc>
-            </a:pPr>
-            <a:r>
-              <a:rPr sz="1380" b="0" i="0">
-                <a:solidFill>
-                  <a:srgbClr val="2B2C30"/>
-                </a:solidFill>
-                <a:latin typeface="Courier New"/>
-              </a:rPr>
-              <a:t>  template_stage1.md          mandatory 7-step scoring procedure</a:t>
-            </a:r>
-          </a:p>
-          <a:p>
-            <a:pPr algn="l">
-              <a:lnSpc>
-                <a:spcPct val="118000"/>
-              </a:lnSpc>
-            </a:pPr>
-            <a:r>
-              <a:rPr sz="1380" b="0" i="0">
-                <a:solidFill>
-                  <a:srgbClr val="2B2C30"/>
-                </a:solidFill>
-                <a:latin typeface="Courier New"/>
-              </a:rPr>
-              <a:t>  template_stage2.md          feedback + reviewer-safety rules</a:t>
-            </a:r>
-          </a:p>
-          <a:p>
-            <a:pPr algn="l">
-              <a:lnSpc>
-                <a:spcPct val="118000"/>
-              </a:lnSpc>
-            </a:pPr>
-            <a:r>
-              <a:rPr sz="1380" b="0" i="0">
-                <a:solidFill>
-                  <a:srgbClr val="2B2C30"/>
-                </a:solidFill>
-                <a:latin typeface="Courier New"/>
-              </a:rPr>
-              <a:t>  evaluation_principles.md    course-level grading philosophy</a:t>
-            </a:r>
-          </a:p>
-          <a:p>
-            <a:pPr algn="l">
-              <a:lnSpc>
-                <a:spcPct val="118000"/>
-              </a:lnSpc>
-            </a:pPr>
-            <a:r>
-              <a:rPr sz="1380" b="0" i="0">
-                <a:solidFill>
-                  <a:srgbClr val="2B2C30"/>
-                </a:solidFill>
-                <a:latin typeface="Courier New"/>
-              </a:rPr>
-              <a:t>  abstract_calibration.md     worked decision examples</a:t>
-            </a:r>
-          </a:p>
-          <a:p>
-            <a:pPr algn="l">
-              <a:lnSpc>
-                <a:spcPct val="118000"/>
-              </a:lnSpc>
-            </a:pPr>
-            <a:r>
-              <a:rPr sz="1380" b="0" i="0">
-                <a:solidFill>
-                  <a:srgbClr val="2B2C30"/>
-                </a:solidFill>
-                <a:latin typeface="Courier New"/>
-              </a:rPr>
-              <a:t>  feedback_style_guide.md     tone, structure, jargon rules</a:t>
-            </a:r>
-          </a:p>
-          <a:p>
-            <a:pPr algn="l">
-              <a:lnSpc>
-                <a:spcPct val="118000"/>
-              </a:lnSpc>
-            </a:pPr>
-            <a:r>
-              <a:rPr sz="1380" b="0" i="0">
-                <a:solidFill>
-                  <a:srgbClr val="2B2C30"/>
-                </a:solidFill>
-                <a:latin typeface="Courier New"/>
-              </a:rPr>
-              <a:t>  ta_operational_baseline.md  how the human baseline was produced</a:t>
-            </a:r>
-          </a:p>
-          <a:p>
-            <a:pPr algn="l">
-              <a:lnSpc>
-                <a:spcPct val="118000"/>
-              </a:lnSpc>
-            </a:pPr>
-            <a:r>
-              <a:rPr sz="1380" b="0" i="0">
-                <a:solidFill>
-                  <a:srgbClr val="2B2C30"/>
-                </a:solidFill>
-                <a:latin typeface="Courier New"/>
-              </a:rPr>
-              <a:t>  schema_stage1.json          149-line JSON contract</a:t>
-            </a:r>
-          </a:p>
-          <a:p>
-            <a:pPr algn="l">
-              <a:lnSpc>
-                <a:spcPct val="118000"/>
-              </a:lnSpc>
-            </a:pPr>
-            <a:r>
-              <a:rPr sz="1380" b="0" i="0">
-                <a:solidFill>
-                  <a:srgbClr val="2B2C30"/>
-                </a:solidFill>
-                <a:latin typeface="Courier New"/>
-              </a:rPr>
-              <a:t>  schema_stage2.json           84-line JSON contract</a:t>
-            </a:r>
-          </a:p>
-          <a:p>
-            <a:pPr algn="l">
-              <a:lnSpc>
-                <a:spcPct val="118000"/>
-              </a:lnSpc>
-            </a:pPr>
-            <a:r>
-              <a:rPr sz="1380" b="0" i="0">
+              <a:rPr sz="971" b="0" i="0">
+                <a:solidFill>
+                  <a:srgbClr val="2B2C30"/>
+                </a:solidFill>
+                <a:latin typeface="Courier New"/>
+              </a:rPr>
+              <a:t>Nothing in src/prompt/ is a finished prompt. Every file is a template</a:t>
+            </a:r>
+          </a:p>
+          <a:p>
+            <a:pPr algn="l">
+              <a:lnSpc>
+                <a:spcPct val="118000"/>
+              </a:lnSpc>
+            </a:pPr>
+            <a:r>
+              <a:rPr sz="971" b="0" i="0">
+                <a:solidFill>
+                  <a:srgbClr val="2B2C30"/>
+                </a:solidFill>
+                <a:latin typeface="Courier New"/>
+              </a:rPr>
+              <a:t>with {{PLACEHOLDER}} slots, filled at two distinct moments.</a:t>
+            </a:r>
+          </a:p>
+          <a:p>
+            <a:pPr algn="l">
+              <a:lnSpc>
+                <a:spcPct val="118000"/>
+              </a:lnSpc>
+            </a:pPr>
+            <a:r>
+              <a:rPr sz="971" b="0" i="0">
                 <a:solidFill>
                   <a:srgbClr val="2B2C30"/>
                 </a:solidFill>
@@ -7861,23 +7649,215 @@
               </a:lnSpc>
             </a:pPr>
             <a:r>
-              <a:rPr sz="1380" b="0" i="0">
-                <a:solidFill>
-                  <a:srgbClr val="2B2C30"/>
-                </a:solidFill>
-                <a:latin typeface="Courier New"/>
-              </a:rPr>
-              <a:t>Rules that exist because the model misbehaved without them:</a:t>
-            </a:r>
-          </a:p>
-          <a:p>
-            <a:pPr algn="l">
-              <a:lnSpc>
-                <a:spcPct val="118000"/>
-              </a:lnSpc>
-            </a:pPr>
-            <a:r>
-              <a:rPr sz="1380" b="0" i="0">
+              <a:rPr sz="971" b="0" i="0">
+                <a:solidFill>
+                  <a:srgbClr val="2B2C30"/>
+                </a:solidFill>
+                <a:latin typeface="Courier New"/>
+              </a:rPr>
+              <a:t>BUILD TIME  --  src/pipeline/02_render_prompts.py</a:t>
+            </a:r>
+          </a:p>
+          <a:p>
+            <a:pPr algn="l">
+              <a:lnSpc>
+                <a:spcPct val="118000"/>
+              </a:lnSpc>
+            </a:pPr>
+            <a:r>
+              <a:rPr sz="971" b="0" i="0">
+                <a:solidFill>
+                  <a:srgbClr val="2B2C30"/>
+                </a:solidFill>
+                <a:latin typeface="Courier New"/>
+              </a:rPr>
+              <a:t>  {{EXPERIMENT_METADATA}}       per-submission JSON: id, role,</a:t>
+            </a:r>
+          </a:p>
+          <a:p>
+            <a:pPr algn="l">
+              <a:lnSpc>
+                <a:spcPct val="118000"/>
+              </a:lnSpc>
+            </a:pPr>
+            <a:r>
+              <a:rPr sz="971" b="0" i="0">
+                <a:solidFill>
+                  <a:srgbClr val="2B2C30"/>
+                </a:solidFill>
+                <a:latin typeface="Courier New"/>
+              </a:rPr>
+              <a:t>                                provider, model, temperature,</a:t>
+            </a:r>
+          </a:p>
+          <a:p>
+            <a:pPr algn="l">
+              <a:lnSpc>
+                <a:spcPct val="118000"/>
+              </a:lnSpc>
+            </a:pPr>
+            <a:r>
+              <a:rPr sz="971" b="0" i="0">
+                <a:solidFill>
+                  <a:srgbClr val="2B2C30"/>
+                </a:solidFill>
+                <a:latin typeface="Courier New"/>
+              </a:rPr>
+              <a:t>                                reasoning_effort, prompt_version</a:t>
+            </a:r>
+          </a:p>
+          <a:p>
+            <a:pPr algn="l">
+              <a:lnSpc>
+                <a:spcPct val="118000"/>
+              </a:lnSpc>
+            </a:pPr>
+            <a:r>
+              <a:rPr sz="971" b="0" i="0">
+                <a:solidFill>
+                  <a:srgbClr val="2B2C30"/>
+                </a:solidFill>
+                <a:latin typeface="Courier New"/>
+              </a:rPr>
+              <a:t>  {{LAB_SPEC_TEXT}}             &lt;- assignment/lab_specification.md</a:t>
+            </a:r>
+          </a:p>
+          <a:p>
+            <a:pPr algn="l">
+              <a:lnSpc>
+                <a:spcPct val="118000"/>
+              </a:lnSpc>
+            </a:pPr>
+            <a:r>
+              <a:rPr sz="971" b="0" i="0">
+                <a:solidFill>
+                  <a:srgbClr val="2B2C30"/>
+                </a:solidFill>
+                <a:latin typeface="Courier New"/>
+              </a:rPr>
+              <a:t>  {{GRADING_SHEET_TEXT}}        &lt;- assignment/grading_reference.md</a:t>
+            </a:r>
+          </a:p>
+          <a:p>
+            <a:pPr algn="l">
+              <a:lnSpc>
+                <a:spcPct val="118000"/>
+              </a:lnSpc>
+            </a:pPr>
+            <a:r>
+              <a:rPr sz="971" b="0" i="0">
+                <a:solidFill>
+                  <a:srgbClr val="2B2C30"/>
+                </a:solidFill>
+                <a:latin typeface="Courier New"/>
+              </a:rPr>
+              <a:t>  {{STARTER_SCAFFOLD_TEXT}}     &lt;- assignment/starter_scaffold.md</a:t>
+            </a:r>
+          </a:p>
+          <a:p>
+            <a:pPr algn="l">
+              <a:lnSpc>
+                <a:spcPct val="118000"/>
+              </a:lnSpc>
+            </a:pPr>
+            <a:r>
+              <a:rPr sz="971" b="0" i="0">
+                <a:solidFill>
+                  <a:srgbClr val="2B2C30"/>
+                </a:solidFill>
+                <a:latin typeface="Courier New"/>
+              </a:rPr>
+              <a:t>  {{RUBRIC_JSON}}               &lt;- rubric.json, gated rubric_ready</a:t>
+            </a:r>
+          </a:p>
+          <a:p>
+            <a:pPr algn="l">
+              <a:lnSpc>
+                <a:spcPct val="118000"/>
+              </a:lnSpc>
+            </a:pPr>
+            <a:r>
+              <a:rPr sz="971" b="0" i="0">
+                <a:solidFill>
+                  <a:srgbClr val="2B2C30"/>
+                </a:solidFill>
+                <a:latin typeface="Courier New"/>
+              </a:rPr>
+              <a:t>  {{CORE_EVALUATION_TEXT}}      &lt;- evaluation_principles.md</a:t>
+            </a:r>
+          </a:p>
+          <a:p>
+            <a:pPr algn="l">
+              <a:lnSpc>
+                <a:spcPct val="118000"/>
+              </a:lnSpc>
+            </a:pPr>
+            <a:r>
+              <a:rPr sz="971" b="0" i="0">
+                <a:solidFill>
+                  <a:srgbClr val="2B2C30"/>
+                </a:solidFill>
+                <a:latin typeface="Courier New"/>
+              </a:rPr>
+              <a:t>  {{ABSTRACT_CALIBRATION_TEXT}} &lt;- abstract_calibration.md</a:t>
+            </a:r>
+          </a:p>
+          <a:p>
+            <a:pPr algn="l">
+              <a:lnSpc>
+                <a:spcPct val="118000"/>
+              </a:lnSpc>
+            </a:pPr>
+            <a:r>
+              <a:rPr sz="971" b="0" i="0">
+                <a:solidFill>
+                  <a:srgbClr val="2B2C30"/>
+                </a:solidFill>
+                <a:latin typeface="Courier New"/>
+              </a:rPr>
+              <a:t>  {{COMMENT_STYLE_TEXT}}        &lt;- feedback_style_guide.md  (st.2)</a:t>
+            </a:r>
+          </a:p>
+          <a:p>
+            <a:pPr algn="l">
+              <a:lnSpc>
+                <a:spcPct val="118000"/>
+              </a:lnSpc>
+            </a:pPr>
+            <a:r>
+              <a:rPr sz="971" b="0" i="0">
+                <a:solidFill>
+                  <a:srgbClr val="2B2C30"/>
+                </a:solidFill>
+                <a:latin typeface="Courier New"/>
+              </a:rPr>
+              <a:t>  {{SUBMISSION_PACKAGE}}        &lt;- submissions/S17.md</a:t>
+            </a:r>
+          </a:p>
+          <a:p>
+            <a:pPr algn="l">
+              <a:lnSpc>
+                <a:spcPct val="118000"/>
+              </a:lnSpc>
+            </a:pPr>
+            <a:r>
+              <a:rPr sz="971" b="0" i="0">
+                <a:solidFill>
+                  <a:srgbClr val="2B2C30"/>
+                </a:solidFill>
+                <a:latin typeface="Courier New"/>
+              </a:rPr>
+              <a:t>  {{OUTPUT_SCHEMA_JSON}}        &lt;- schema_stage{1,2}.json</a:t>
+            </a:r>
+          </a:p>
+          <a:p>
+            <a:pPr algn="l">
+              <a:lnSpc>
+                <a:spcPct val="118000"/>
+              </a:lnSpc>
+            </a:pPr>
+            <a:r>
+              <a:rPr sz="971" b="0" i="0">
                 <a:solidFill>
                   <a:srgbClr val="2B2C30"/>
                 </a:solidFill>
@@ -7893,109 +7873,157 @@
               </a:lnSpc>
             </a:pPr>
             <a:r>
-              <a:rPr sz="1380" b="0" i="0">
-                <a:solidFill>
-                  <a:srgbClr val="2B2C30"/>
-                </a:solidFill>
-                <a:latin typeface="Courier New"/>
-              </a:rPr>
-              <a:t>  "Do not convert optional improvements into point loss"</a:t>
-            </a:r>
-          </a:p>
-          <a:p>
-            <a:pPr algn="l">
-              <a:lnSpc>
-                <a:spcPct val="118000"/>
-              </a:lnSpc>
-            </a:pPr>
-            <a:r>
-              <a:rPr sz="1380" b="0" i="0">
-                <a:solidFill>
-                  <a:srgbClr val="2B2C30"/>
-                </a:solidFill>
-                <a:latin typeface="Courier New"/>
-              </a:rPr>
-              <a:t>      -&gt;  route them to non_penalized_observations[]</a:t>
-            </a:r>
-          </a:p>
-          <a:p>
-            <a:pPr algn="l">
-              <a:lnSpc>
-                <a:spcPct val="118000"/>
-              </a:lnSpc>
-            </a:pPr>
-            <a:r>
-              <a:rPr sz="1380" b="0" i="0">
-                <a:solidFill>
-                  <a:srgbClr val="2B2C30"/>
-                </a:solidFill>
-                <a:latin typeface="Courier New"/>
-              </a:rPr>
-              <a:t>  "Avoid double jeopardy: one root cause, one deduction"</a:t>
-            </a:r>
-          </a:p>
-          <a:p>
-            <a:pPr algn="l">
-              <a:lnSpc>
-                <a:spcPct val="118000"/>
-              </a:lnSpc>
-            </a:pPr>
-            <a:r>
-              <a:rPr sz="1380" b="0" i="0">
-                <a:solidFill>
-                  <a:srgbClr val="2B2C30"/>
-                </a:solidFill>
-                <a:latin typeface="Courier New"/>
-              </a:rPr>
-              <a:t>  "Do not penalize naming, formatting, casing or punctuation"</a:t>
-            </a:r>
-          </a:p>
-          <a:p>
-            <a:pPr algn="l">
-              <a:lnSpc>
-                <a:spcPct val="118000"/>
-              </a:lnSpc>
-            </a:pPr>
-            <a:r>
-              <a:rPr sz="1380" b="0" i="0">
-                <a:solidFill>
-                  <a:srgbClr val="2B2C30"/>
-                </a:solidFill>
-                <a:latin typeface="Courier New"/>
-              </a:rPr>
-              <a:t>  "minor .25-1.0 | moderate 1.0-2.5 | major 2.5-5 | blocking 5-10"</a:t>
-            </a:r>
-          </a:p>
-          <a:p>
-            <a:pPr algn="l">
-              <a:lnSpc>
-                <a:spcPct val="118000"/>
-              </a:lnSpc>
-            </a:pPr>
-            <a:r>
-              <a:rPr sz="1380" b="0" i="0">
-                <a:solidFill>
-                  <a:srgbClr val="2B2C30"/>
-                </a:solidFill>
-                <a:latin typeface="Courier New"/>
-              </a:rPr>
-              <a:t>  "If confidence is low, omit it from student feedback and</a:t>
-            </a:r>
-          </a:p>
-          <a:p>
-            <a:pPr algn="l">
-              <a:lnSpc>
-                <a:spcPct val="118000"/>
-              </a:lnSpc>
-            </a:pPr>
-            <a:r>
-              <a:rPr sz="1380" b="0" i="0">
-                <a:solidFill>
-                  <a:srgbClr val="2B2C30"/>
-                </a:solidFill>
-                <a:latin typeface="Courier New"/>
-              </a:rPr>
-              <a:t>   record the omission in reviewer_notes"</a:t>
+              <a:rPr sz="971" b="0" i="0">
+                <a:solidFill>
+                  <a:srgbClr val="2B2C30"/>
+                </a:solidFill>
+                <a:latin typeface="Courier New"/>
+              </a:rPr>
+              <a:t>RUN TIME  --  src/pipeline/utils/llm_execution.py</a:t>
+            </a:r>
+          </a:p>
+          <a:p>
+            <a:pPr algn="l">
+              <a:lnSpc>
+                <a:spcPct val="118000"/>
+              </a:lnSpc>
+            </a:pPr>
+            <a:r>
+              <a:rPr sz="971" b="0" i="0">
+                <a:solidFill>
+                  <a:srgbClr val="2B2C30"/>
+                </a:solidFill>
+                <a:latin typeface="Courier New"/>
+              </a:rPr>
+              <a:t>  {{STAGE1_JSON}}   left UNRESOLVED on disk on purpose, then swapped</a:t>
+            </a:r>
+          </a:p>
+          <a:p>
+            <a:pPr algn="l">
+              <a:lnSpc>
+                <a:spcPct val="118000"/>
+              </a:lnSpc>
+            </a:pPr>
+            <a:r>
+              <a:rPr sz="971" b="0" i="0">
+                <a:solidFill>
+                  <a:srgbClr val="2B2C30"/>
+                </a:solidFill>
+                <a:latin typeface="Courier New"/>
+              </a:rPr>
+              <a:t>                    at call time for the parsed, re-serialized</a:t>
+            </a:r>
+          </a:p>
+          <a:p>
+            <a:pPr algn="l">
+              <a:lnSpc>
+                <a:spcPct val="118000"/>
+              </a:lnSpc>
+            </a:pPr>
+            <a:r>
+              <a:rPr sz="971" b="0" i="0">
+                <a:solidFill>
+                  <a:srgbClr val="2B2C30"/>
+                </a:solidFill>
+                <a:latin typeface="Courier New"/>
+              </a:rPr>
+              <a:t>                    stage 1 response</a:t>
+            </a:r>
+          </a:p>
+          <a:p>
+            <a:pPr algn="l">
+              <a:lnSpc>
+                <a:spcPct val="118000"/>
+              </a:lnSpc>
+            </a:pPr>
+            <a:r>
+              <a:rPr sz="971" b="0" i="0">
+                <a:solidFill>
+                  <a:srgbClr val="2B2C30"/>
+                </a:solidFill>
+                <a:latin typeface="Courier New"/>
+              </a:rPr>
+              <a:t/>
+            </a:r>
+          </a:p>
+          <a:p>
+            <a:pPr algn="l">
+              <a:lnSpc>
+                <a:spcPct val="118000"/>
+              </a:lnSpc>
+            </a:pPr>
+            <a:r>
+              <a:rPr sz="971" b="0" i="0">
+                <a:solidFill>
+                  <a:srgbClr val="2B2C30"/>
+                </a:solidFill>
+                <a:latin typeface="Courier New"/>
+              </a:rPr>
+              <a:t>  stage 1:  9 slots resolved   136-line template  -&gt;  1753 lines</a:t>
+            </a:r>
+          </a:p>
+          <a:p>
+            <a:pPr algn="l">
+              <a:lnSpc>
+                <a:spcPct val="118000"/>
+              </a:lnSpc>
+            </a:pPr>
+            <a:r>
+              <a:rPr sz="971" b="0" i="0">
+                <a:solidFill>
+                  <a:srgbClr val="2B2C30"/>
+                </a:solidFill>
+                <a:latin typeface="Courier New"/>
+              </a:rPr>
+              <a:t>  stage 2:  1 slot left open   grep the shipped file, it is there</a:t>
+            </a:r>
+          </a:p>
+          <a:p>
+            <a:pPr algn="l">
+              <a:lnSpc>
+                <a:spcPct val="118000"/>
+              </a:lnSpc>
+            </a:pPr>
+            <a:r>
+              <a:rPr sz="971" b="0" i="0">
+                <a:solidFill>
+                  <a:srgbClr val="2B2C30"/>
+                </a:solidFill>
+                <a:latin typeface="Courier New"/>
+              </a:rPr>
+              <a:t/>
+            </a:r>
+          </a:p>
+          <a:p>
+            <a:pPr algn="l">
+              <a:lnSpc>
+                <a:spcPct val="118000"/>
+              </a:lnSpc>
+            </a:pPr>
+            <a:r>
+              <a:rPr sz="971" b="0" i="0">
+                <a:solidFill>
+                  <a:srgbClr val="2B2C30"/>
+                </a:solidFill>
+                <a:latin typeface="Courier New"/>
+              </a:rPr>
+              <a:t>So stage 2 never sees raw model prose, only re-parsed JSON - and the</a:t>
+            </a:r>
+          </a:p>
+          <a:p>
+            <a:pPr algn="l">
+              <a:lnSpc>
+                <a:spcPct val="118000"/>
+              </a:lnSpc>
+            </a:pPr>
+            <a:r>
+              <a:rPr sz="971" b="0" i="0">
+                <a:solidFill>
+                  <a:srgbClr val="2B2C30"/>
+                </a:solidFill>
+                <a:latin typeface="Courier New"/>
+              </a:rPr>
+              <a:t>1008 rendered files are the audit trail of what we actually sent.</a:t>
             </a:r>
           </a:p>
         </p:txBody>
@@ -8090,7 +8118,7 @@
                 </a:solidFill>
                 <a:latin typeface="Public Sans"/>
               </a:rPr>
-              <a:t>HOW THE STUDY WAS RUN</a:t>
+              <a:t>THE PROMPT (3/3): THE GUARDRAILS</a:t>
             </a:r>
           </a:p>
         </p:txBody>
@@ -8164,7 +8192,7 @@
                 </a:solidFill>
                 <a:latin typeface="Courier New"/>
               </a:rPr>
-              <a:t>PHASE 1  -  INPUTS</a:t>
+              <a:t>src/prompt/</a:t>
             </a:r>
           </a:p>
           <a:p>
@@ -8180,7 +8208,7 @@
                 </a:solidFill>
                 <a:latin typeface="Courier New"/>
               </a:rPr>
-              <a:t>  84 Java submissions, anonymized: author lines masked, repository</a:t>
+              <a:t>  template_stage1.md          mandatory 7-step scoring procedure</a:t>
             </a:r>
           </a:p>
           <a:p>
@@ -8196,7 +8224,7 @@
                 </a:solidFill>
                 <a:latin typeface="Courier New"/>
               </a:rPr>
-              <a:t>  names replaced, identifiers reduced to S01..S84</a:t>
+              <a:t>  template_stage2.md          feedback + reviewer-safety rules</a:t>
             </a:r>
           </a:p>
           <a:p>
@@ -8212,7 +8240,7 @@
                 </a:solidFill>
                 <a:latin typeface="Courier New"/>
               </a:rPr>
-              <a:t>  official rubric: 7 criteria, 0-10, core 60% / supporting 40%</a:t>
+              <a:t>  evaluation_principles.md    course-level grading philosophy</a:t>
             </a:r>
           </a:p>
           <a:p>
@@ -8228,6 +8256,86 @@
                 </a:solidFill>
                 <a:latin typeface="Courier New"/>
               </a:rPr>
+              <a:t>  abstract_calibration.md     worked decision examples</a:t>
+            </a:r>
+          </a:p>
+          <a:p>
+            <a:pPr algn="l">
+              <a:lnSpc>
+                <a:spcPct val="118000"/>
+              </a:lnSpc>
+            </a:pPr>
+            <a:r>
+              <a:rPr sz="1380" b="0" i="0">
+                <a:solidFill>
+                  <a:srgbClr val="2B2C30"/>
+                </a:solidFill>
+                <a:latin typeface="Courier New"/>
+              </a:rPr>
+              <a:t>  feedback_style_guide.md     tone, structure, jargon rules</a:t>
+            </a:r>
+          </a:p>
+          <a:p>
+            <a:pPr algn="l">
+              <a:lnSpc>
+                <a:spcPct val="118000"/>
+              </a:lnSpc>
+            </a:pPr>
+            <a:r>
+              <a:rPr sz="1380" b="0" i="0">
+                <a:solidFill>
+                  <a:srgbClr val="2B2C30"/>
+                </a:solidFill>
+                <a:latin typeface="Courier New"/>
+              </a:rPr>
+              <a:t>  ta_operational_baseline.md  how the human baseline was produced</a:t>
+            </a:r>
+          </a:p>
+          <a:p>
+            <a:pPr algn="l">
+              <a:lnSpc>
+                <a:spcPct val="118000"/>
+              </a:lnSpc>
+            </a:pPr>
+            <a:r>
+              <a:rPr sz="1380" b="0" i="0">
+                <a:solidFill>
+                  <a:srgbClr val="2B2C30"/>
+                </a:solidFill>
+                <a:latin typeface="Courier New"/>
+              </a:rPr>
+              <a:t>  schema_stage1.json          149-line JSON contract</a:t>
+            </a:r>
+          </a:p>
+          <a:p>
+            <a:pPr algn="l">
+              <a:lnSpc>
+                <a:spcPct val="118000"/>
+              </a:lnSpc>
+            </a:pPr>
+            <a:r>
+              <a:rPr sz="1380" b="0" i="0">
+                <a:solidFill>
+                  <a:srgbClr val="2B2C30"/>
+                </a:solidFill>
+                <a:latin typeface="Courier New"/>
+              </a:rPr>
+              <a:t>  schema_stage2.json           84-line JSON contract</a:t>
+            </a:r>
+          </a:p>
+          <a:p>
+            <a:pPr algn="l">
+              <a:lnSpc>
+                <a:spcPct val="118000"/>
+              </a:lnSpc>
+            </a:pPr>
+            <a:r>
+              <a:rPr sz="1380" b="0" i="0">
+                <a:solidFill>
+                  <a:srgbClr val="2B2C30"/>
+                </a:solidFill>
+                <a:latin typeface="Courier New"/>
+              </a:rPr>
               <a:t/>
             </a:r>
           </a:p>
@@ -8244,7 +8352,7 @@
                 </a:solidFill>
                 <a:latin typeface="Courier New"/>
               </a:rPr>
-              <a:t>PHASE 2  -  EVALUATION</a:t>
+              <a:t>Rules that exist because the model misbehaved without them:</a:t>
             </a:r>
           </a:p>
           <a:p>
@@ -8260,7 +8368,7 @@
                 </a:solidFill>
                 <a:latin typeface="Courier New"/>
               </a:rPr>
-              <a:t>  TA grades .......... the operational human baseline, 28 TAs</a:t>
+              <a:t/>
             </a:r>
           </a:p>
           <a:p>
@@ -8276,7 +8384,7 @@
                 </a:solidFill>
                 <a:latin typeface="Courier New"/>
               </a:rPr>
-              <a:t>  expert reference ... rubric scores + 361 annotated issues</a:t>
+              <a:t>  "Do not convert optional improvements into point loss"</a:t>
             </a:r>
           </a:p>
           <a:p>
@@ -8292,7 +8400,7 @@
                 </a:solidFill>
                 <a:latin typeface="Courier New"/>
               </a:rPr>
-              <a:t>                       over a 12-category taxonomy</a:t>
+              <a:t>      -&gt;  route them to non_penalized_observations[]</a:t>
             </a:r>
           </a:p>
           <a:p>
@@ -8308,7 +8416,7 @@
                 </a:solidFill>
                 <a:latin typeface="Courier New"/>
               </a:rPr>
-              <a:t>  LLM assessments .... Gemini 3.1 Pro and GPT-5.5, stage 1 -&gt; 2,</a:t>
+              <a:t>  "Avoid double jeopardy: one root cause, one deduction"</a:t>
             </a:r>
           </a:p>
           <a:p>
@@ -8324,7 +8432,7 @@
                 </a:solidFill>
                 <a:latin typeface="Courier New"/>
               </a:rPr>
-              <a:t>                       temperature 0, 3 runs each = 504 assessments</a:t>
+              <a:t>  "Do not penalize naming, formatting, casing or punctuation"</a:t>
             </a:r>
           </a:p>
           <a:p>
@@ -8340,7 +8448,7 @@
                 </a:solidFill>
                 <a:latin typeface="Courier New"/>
               </a:rPr>
-              <a:t/>
+              <a:t>  "minor .25-1.0 | moderate 1.0-2.5 | major 2.5-5 | blocking 5-10"</a:t>
             </a:r>
           </a:p>
           <a:p>
@@ -8356,7 +8464,7 @@
                 </a:solidFill>
                 <a:latin typeface="Courier New"/>
               </a:rPr>
-              <a:t>PHASE 3  -  ANALYSIS</a:t>
+              <a:t>  "If confidence is low, omit it from student feedback and</a:t>
             </a:r>
           </a:p>
           <a:p>
@@ -8372,87 +8480,7 @@
                 </a:solidFill>
                 <a:latin typeface="Courier New"/>
               </a:rPr>
-              <a:t>  RQ1  grade concordance ... MAE, RMSE, bias, tolerance bands</a:t>
-            </a:r>
-          </a:p>
-          <a:p>
-            <a:pPr algn="l">
-              <a:lnSpc>
-                <a:spcPct val="118000"/>
-              </a:lnSpc>
-            </a:pPr>
-            <a:r>
-              <a:rPr sz="1380" b="0" i="0">
-                <a:solidFill>
-                  <a:srgbClr val="2B2C30"/>
-                </a:solidFill>
-                <a:latin typeface="Courier New"/>
-              </a:rPr>
-              <a:t>  RQ2  problem alignment ... precision, recall, F1</a:t>
-            </a:r>
-          </a:p>
-          <a:p>
-            <a:pPr algn="l">
-              <a:lnSpc>
-                <a:spcPct val="118000"/>
-              </a:lnSpc>
-            </a:pPr>
-            <a:r>
-              <a:rPr sz="1380" b="0" i="0">
-                <a:solidFill>
-                  <a:srgbClr val="2B2C30"/>
-                </a:solidFill>
-                <a:latin typeface="Courier New"/>
-              </a:rPr>
-              <a:t>  stability ................ ICC(2,1), run-pair MAE, exact agreement</a:t>
-            </a:r>
-          </a:p>
-          <a:p>
-            <a:pPr algn="l">
-              <a:lnSpc>
-                <a:spcPct val="118000"/>
-              </a:lnSpc>
-            </a:pPr>
-            <a:r>
-              <a:rPr sz="1380" b="0" i="0">
-                <a:solidFill>
-                  <a:srgbClr val="2B2C30"/>
-                </a:solidFill>
-                <a:latin typeface="Courier New"/>
-              </a:rPr>
-              <a:t/>
-            </a:r>
-          </a:p>
-          <a:p>
-            <a:pPr algn="l">
-              <a:lnSpc>
-                <a:spcPct val="118000"/>
-              </a:lnSpc>
-            </a:pPr>
-            <a:r>
-              <a:rPr sz="1380" b="0" i="0">
-                <a:solidFill>
-                  <a:srgbClr val="2B2C30"/>
-                </a:solidFill>
-                <a:latin typeface="Courier New"/>
-              </a:rPr>
-              <a:t>Each run directory is self-contained: experiment_config.json, inputs,</a:t>
-            </a:r>
-          </a:p>
-          <a:p>
-            <a:pPr algn="l">
-              <a:lnSpc>
-                <a:spcPct val="118000"/>
-              </a:lnSpc>
-            </a:pPr>
-            <a:r>
-              <a:rPr sz="1380" b="0" i="0">
-                <a:solidFill>
-                  <a:srgbClr val="2B2C30"/>
-                </a:solidFill>
-                <a:latin typeface="Courier New"/>
-              </a:rPr>
-              <a:t>the rendered prompt, raw parse, normalized output, validation report.</a:t>
+              <a:t>   record the omission in reviewer_notes"</a:t>
             </a:r>
           </a:p>
         </p:txBody>
@@ -8547,7 +8575,7 @@
                 </a:solidFill>
                 <a:latin typeface="Public Sans"/>
               </a:rPr>
-              <a:t>THE HARD MEASUREMENT: IS IT THE SAME PROBLEM?</a:t>
+              <a:t>HOW THE STUDY WAS RUN</a:t>
             </a:r>
           </a:p>
         </p:txBody>
@@ -8615,23 +8643,71 @@
               </a:lnSpc>
             </a:pPr>
             <a:r>
-              <a:rPr sz="1456" b="0" i="0">
-                <a:solidFill>
-                  <a:srgbClr val="2B2C30"/>
-                </a:solidFill>
-                <a:latin typeface="Courier New"/>
-              </a:rPr>
-              <a:t>String equality fails. Taxonomy overlap is too generous.</a:t>
-            </a:r>
-          </a:p>
-          <a:p>
-            <a:pPr algn="l">
-              <a:lnSpc>
-                <a:spcPct val="118000"/>
-              </a:lnSpc>
-            </a:pPr>
-            <a:r>
-              <a:rPr sz="1456" b="0" i="0">
+              <a:rPr sz="1380" b="0" i="0">
+                <a:solidFill>
+                  <a:srgbClr val="2B2C30"/>
+                </a:solidFill>
+                <a:latin typeface="Courier New"/>
+              </a:rPr>
+              <a:t>PHASE 1  -  INPUTS</a:t>
+            </a:r>
+          </a:p>
+          <a:p>
+            <a:pPr algn="l">
+              <a:lnSpc>
+                <a:spcPct val="118000"/>
+              </a:lnSpc>
+            </a:pPr>
+            <a:r>
+              <a:rPr sz="1380" b="0" i="0">
+                <a:solidFill>
+                  <a:srgbClr val="2B2C30"/>
+                </a:solidFill>
+                <a:latin typeface="Courier New"/>
+              </a:rPr>
+              <a:t>  84 Java submissions, anonymized: author lines masked, repository</a:t>
+            </a:r>
+          </a:p>
+          <a:p>
+            <a:pPr algn="l">
+              <a:lnSpc>
+                <a:spcPct val="118000"/>
+              </a:lnSpc>
+            </a:pPr>
+            <a:r>
+              <a:rPr sz="1380" b="0" i="0">
+                <a:solidFill>
+                  <a:srgbClr val="2B2C30"/>
+                </a:solidFill>
+                <a:latin typeface="Courier New"/>
+              </a:rPr>
+              <a:t>  names replaced, identifiers reduced to S01..S84</a:t>
+            </a:r>
+          </a:p>
+          <a:p>
+            <a:pPr algn="l">
+              <a:lnSpc>
+                <a:spcPct val="118000"/>
+              </a:lnSpc>
+            </a:pPr>
+            <a:r>
+              <a:rPr sz="1380" b="0" i="0">
+                <a:solidFill>
+                  <a:srgbClr val="2B2C30"/>
+                </a:solidFill>
+                <a:latin typeface="Courier New"/>
+              </a:rPr>
+              <a:t>  official rubric: 7 criteria, 0-10, core 60% / supporting 40%</a:t>
+            </a:r>
+          </a:p>
+          <a:p>
+            <a:pPr algn="l">
+              <a:lnSpc>
+                <a:spcPct val="118000"/>
+              </a:lnSpc>
+            </a:pPr>
+            <a:r>
+              <a:rPr sz="1380" b="0" i="0">
                 <a:solidFill>
                   <a:srgbClr val="2B2C30"/>
                 </a:solidFill>
@@ -8647,215 +8723,103 @@
               </a:lnSpc>
             </a:pPr>
             <a:r>
-              <a:rPr sz="1456" b="0" i="0">
-                <a:solidFill>
-                  <a:srgbClr val="2B2C30"/>
-                </a:solidFill>
-                <a:latin typeface="Courier New"/>
-              </a:rPr>
-              <a:t>  expert  (S17, class_modeling)     model  (S17, class_modeling)</a:t>
-            </a:r>
-          </a:p>
-          <a:p>
-            <a:pPr algn="l">
-              <a:lnSpc>
-                <a:spcPct val="118000"/>
-              </a:lnSpc>
-            </a:pPr>
-            <a:r>
-              <a:rPr sz="1456" b="0" i="0">
-                <a:solidFill>
-                  <a:srgbClr val="2B2C30"/>
-                </a:solidFill>
-                <a:latin typeface="Courier New"/>
-              </a:rPr>
-              <a:t>  "Filme has no encapsulation,      "attributes of Filme are public,</a:t>
-            </a:r>
-          </a:p>
-          <a:p>
-            <a:pPr algn="l">
-              <a:lnSpc>
-                <a:spcPct val="118000"/>
-              </a:lnSpc>
-            </a:pPr>
-            <a:r>
-              <a:rPr sz="1456" b="0" i="0">
-                <a:solidFill>
-                  <a:srgbClr val="2B2C30"/>
-                </a:solidFill>
-                <a:latin typeface="Courier New"/>
-              </a:rPr>
-              <a:t>   attributes are public"            information hiding is broken"</a:t>
-            </a:r>
-          </a:p>
-          <a:p>
-            <a:pPr algn="l">
-              <a:lnSpc>
-                <a:spcPct val="118000"/>
-              </a:lnSpc>
-            </a:pPr>
-            <a:r>
-              <a:rPr sz="1456" b="0" i="0">
-                <a:solidFill>
-                  <a:srgbClr val="2B2C30"/>
-                </a:solidFill>
-                <a:latin typeface="Courier New"/>
-              </a:rPr>
-              <a:t>                    \                    /</a:t>
-            </a:r>
-          </a:p>
-          <a:p>
-            <a:pPr algn="l">
-              <a:lnSpc>
-                <a:spcPct val="118000"/>
-              </a:lnSpc>
-            </a:pPr>
-            <a:r>
-              <a:rPr sz="1456" b="0" i="0">
-                <a:solidFill>
-                  <a:srgbClr val="2B2C30"/>
-                </a:solidFill>
-                <a:latin typeface="Courier New"/>
-              </a:rPr>
-              <a:t>                     v                  v</a:t>
-            </a:r>
-          </a:p>
-          <a:p>
-            <a:pPr algn="l">
-              <a:lnSpc>
-                <a:spcPct val="118000"/>
-              </a:lnSpc>
-            </a:pPr>
-            <a:r>
-              <a:rPr sz="1456" b="0" i="0">
-                <a:solidFill>
-                  <a:srgbClr val="2B2C30"/>
-                </a:solidFill>
-                <a:latin typeface="Courier New"/>
-              </a:rPr>
-              <a:t>        +-----------------------------------------+</a:t>
-            </a:r>
-          </a:p>
-          <a:p>
-            <a:pPr algn="l">
-              <a:lnSpc>
-                <a:spcPct val="118000"/>
-              </a:lnSpc>
-            </a:pPr>
-            <a:r>
-              <a:rPr sz="1456" b="0" i="0">
-                <a:solidFill>
-                  <a:srgbClr val="2B2C30"/>
-                </a:solidFill>
-                <a:latin typeface="Courier New"/>
-              </a:rPr>
-              <a:t>        |  adjudicator: Claude Sonnet 5           |  a third</a:t>
-            </a:r>
-          </a:p>
-          <a:p>
-            <a:pPr algn="l">
-              <a:lnSpc>
-                <a:spcPct val="118000"/>
-              </a:lnSpc>
-            </a:pPr>
-            <a:r>
-              <a:rPr sz="1456" b="0" i="0">
-                <a:solidFill>
-                  <a:srgbClr val="2B2C30"/>
-                </a:solidFill>
-                <a:latin typeface="Courier New"/>
-              </a:rPr>
-              <a:t>        |  temperature 0, structured JSON out     |  provider</a:t>
-            </a:r>
-          </a:p>
-          <a:p>
-            <a:pPr algn="l">
-              <a:lnSpc>
-                <a:spcPct val="118000"/>
-              </a:lnSpc>
-            </a:pPr>
-            <a:r>
-              <a:rPr sz="1456" b="0" i="0">
-                <a:solidFill>
-                  <a:srgbClr val="2B2C30"/>
-                </a:solidFill>
-                <a:latin typeface="Courier New"/>
-              </a:rPr>
-              <a:t>        |  scoped to submission_id | criterion    |  family, so</a:t>
-            </a:r>
-          </a:p>
-          <a:p>
-            <a:pPr algn="l">
-              <a:lnSpc>
-                <a:spcPct val="118000"/>
-              </a:lnSpc>
-            </a:pPr>
-            <a:r>
-              <a:rPr sz="1456" b="0" i="0">
-                <a:solidFill>
-                  <a:srgbClr val="2B2C30"/>
-                </a:solidFill>
-                <a:latin typeface="Courier New"/>
-              </a:rPr>
-              <a:t>        |  subsumption + many-to-many allowed     |  no home-</a:t>
-            </a:r>
-          </a:p>
-          <a:p>
-            <a:pPr algn="l">
-              <a:lnSpc>
-                <a:spcPct val="118000"/>
-              </a:lnSpc>
-            </a:pPr>
-            <a:r>
-              <a:rPr sz="1456" b="0" i="0">
-                <a:solidFill>
-                  <a:srgbClr val="2B2C30"/>
-                </a:solidFill>
-                <a:latin typeface="Courier New"/>
-              </a:rPr>
-              <a:t>        +-----------------------------------------+  team bias</a:t>
-            </a:r>
-          </a:p>
-          <a:p>
-            <a:pPr algn="l">
-              <a:lnSpc>
-                <a:spcPct val="118000"/>
-              </a:lnSpc>
-            </a:pPr>
-            <a:r>
-              <a:rPr sz="1456" b="0" i="0">
-                <a:solidFill>
-                  <a:srgbClr val="2B2C30"/>
-                </a:solidFill>
-                <a:latin typeface="Courier New"/>
-              </a:rPr>
-              <a:t>                            |</a:t>
-            </a:r>
-          </a:p>
-          <a:p>
-            <a:pPr algn="l">
-              <a:lnSpc>
-                <a:spcPct val="118000"/>
-              </a:lnSpc>
-            </a:pPr>
-            <a:r>
-              <a:rPr sz="1456" b="0" i="0">
-                <a:solidFill>
-                  <a:srgbClr val="2B2C30"/>
-                </a:solidFill>
-                <a:latin typeface="Courier New"/>
-              </a:rPr>
-              <a:t>    covered_expert = TP   uncovered_expert = FN   unmatched_llm = FP</a:t>
-            </a:r>
-          </a:p>
-          <a:p>
-            <a:pPr algn="l">
-              <a:lnSpc>
-                <a:spcPct val="118000"/>
-              </a:lnSpc>
-            </a:pPr>
-            <a:r>
-              <a:rPr sz="1456" b="0" i="0">
+              <a:rPr sz="1380" b="0" i="0">
+                <a:solidFill>
+                  <a:srgbClr val="2B2C30"/>
+                </a:solidFill>
+                <a:latin typeface="Courier New"/>
+              </a:rPr>
+              <a:t>PHASE 2  -  EVALUATION</a:t>
+            </a:r>
+          </a:p>
+          <a:p>
+            <a:pPr algn="l">
+              <a:lnSpc>
+                <a:spcPct val="118000"/>
+              </a:lnSpc>
+            </a:pPr>
+            <a:r>
+              <a:rPr sz="1380" b="0" i="0">
+                <a:solidFill>
+                  <a:srgbClr val="2B2C30"/>
+                </a:solidFill>
+                <a:latin typeface="Courier New"/>
+              </a:rPr>
+              <a:t>  TA grades .......... the operational human baseline, 28 TAs</a:t>
+            </a:r>
+          </a:p>
+          <a:p>
+            <a:pPr algn="l">
+              <a:lnSpc>
+                <a:spcPct val="118000"/>
+              </a:lnSpc>
+            </a:pPr>
+            <a:r>
+              <a:rPr sz="1380" b="0" i="0">
+                <a:solidFill>
+                  <a:srgbClr val="2B2C30"/>
+                </a:solidFill>
+                <a:latin typeface="Courier New"/>
+              </a:rPr>
+              <a:t>  expert reference ... rubric scores + 361 annotated issues</a:t>
+            </a:r>
+          </a:p>
+          <a:p>
+            <a:pPr algn="l">
+              <a:lnSpc>
+                <a:spcPct val="118000"/>
+              </a:lnSpc>
+            </a:pPr>
+            <a:r>
+              <a:rPr sz="1380" b="0" i="0">
+                <a:solidFill>
+                  <a:srgbClr val="2B2C30"/>
+                </a:solidFill>
+                <a:latin typeface="Courier New"/>
+              </a:rPr>
+              <a:t>                       over a 12-category taxonomy</a:t>
+            </a:r>
+          </a:p>
+          <a:p>
+            <a:pPr algn="l">
+              <a:lnSpc>
+                <a:spcPct val="118000"/>
+              </a:lnSpc>
+            </a:pPr>
+            <a:r>
+              <a:rPr sz="1380" b="0" i="0">
+                <a:solidFill>
+                  <a:srgbClr val="2B2C30"/>
+                </a:solidFill>
+                <a:latin typeface="Courier New"/>
+              </a:rPr>
+              <a:t>  LLM assessments .... Gemini 3.1 Pro and GPT-5.5, stage 1 -&gt; 2,</a:t>
+            </a:r>
+          </a:p>
+          <a:p>
+            <a:pPr algn="l">
+              <a:lnSpc>
+                <a:spcPct val="118000"/>
+              </a:lnSpc>
+            </a:pPr>
+            <a:r>
+              <a:rPr sz="1380" b="0" i="0">
+                <a:solidFill>
+                  <a:srgbClr val="2B2C30"/>
+                </a:solidFill>
+                <a:latin typeface="Courier New"/>
+              </a:rPr>
+              <a:t>                       temperature 0, 3 runs each = 504 assessments</a:t>
+            </a:r>
+          </a:p>
+          <a:p>
+            <a:pPr algn="l">
+              <a:lnSpc>
+                <a:spcPct val="118000"/>
+              </a:lnSpc>
+            </a:pPr>
+            <a:r>
+              <a:rPr sz="1380" b="0" i="0">
                 <a:solidFill>
                   <a:srgbClr val="2B2C30"/>
                 </a:solidFill>
@@ -8871,29 +8835,109 @@
               </a:lnSpc>
             </a:pPr>
             <a:r>
-              <a:rPr sz="1456" b="0" i="0">
-                <a:solidFill>
-                  <a:srgbClr val="2B2C30"/>
-                </a:solidFill>
-                <a:latin typeface="Courier New"/>
-              </a:rPr>
-              <a:t>The prompt, the model id and every cache entry ship in the artifact.</a:t>
-            </a:r>
-          </a:p>
-          <a:p>
-            <a:pPr algn="l">
-              <a:lnSpc>
-                <a:spcPct val="118000"/>
-              </a:lnSpc>
-            </a:pPr>
-            <a:r>
-              <a:rPr sz="1456" b="0" i="0">
-                <a:solidFill>
-                  <a:srgbClr val="2B2C30"/>
-                </a:solidFill>
-                <a:latin typeface="Courier New"/>
-              </a:rPr>
-              <a:t>Sensitivity check: reversing 10 decisions shifts P/R by under 0.04.</a:t>
+              <a:rPr sz="1380" b="0" i="0">
+                <a:solidFill>
+                  <a:srgbClr val="2B2C30"/>
+                </a:solidFill>
+                <a:latin typeface="Courier New"/>
+              </a:rPr>
+              <a:t>PHASE 3  -  ANALYSIS</a:t>
+            </a:r>
+          </a:p>
+          <a:p>
+            <a:pPr algn="l">
+              <a:lnSpc>
+                <a:spcPct val="118000"/>
+              </a:lnSpc>
+            </a:pPr>
+            <a:r>
+              <a:rPr sz="1380" b="0" i="0">
+                <a:solidFill>
+                  <a:srgbClr val="2B2C30"/>
+                </a:solidFill>
+                <a:latin typeface="Courier New"/>
+              </a:rPr>
+              <a:t>  RQ1  grade concordance ... MAE, RMSE, bias, tolerance bands</a:t>
+            </a:r>
+          </a:p>
+          <a:p>
+            <a:pPr algn="l">
+              <a:lnSpc>
+                <a:spcPct val="118000"/>
+              </a:lnSpc>
+            </a:pPr>
+            <a:r>
+              <a:rPr sz="1380" b="0" i="0">
+                <a:solidFill>
+                  <a:srgbClr val="2B2C30"/>
+                </a:solidFill>
+                <a:latin typeface="Courier New"/>
+              </a:rPr>
+              <a:t>  RQ2  problem alignment ... precision, recall, F1</a:t>
+            </a:r>
+          </a:p>
+          <a:p>
+            <a:pPr algn="l">
+              <a:lnSpc>
+                <a:spcPct val="118000"/>
+              </a:lnSpc>
+            </a:pPr>
+            <a:r>
+              <a:rPr sz="1380" b="0" i="0">
+                <a:solidFill>
+                  <a:srgbClr val="2B2C30"/>
+                </a:solidFill>
+                <a:latin typeface="Courier New"/>
+              </a:rPr>
+              <a:t>  stability ................ ICC(2,1), run-pair MAE, exact agreement</a:t>
+            </a:r>
+          </a:p>
+          <a:p>
+            <a:pPr algn="l">
+              <a:lnSpc>
+                <a:spcPct val="118000"/>
+              </a:lnSpc>
+            </a:pPr>
+            <a:r>
+              <a:rPr sz="1380" b="0" i="0">
+                <a:solidFill>
+                  <a:srgbClr val="2B2C30"/>
+                </a:solidFill>
+                <a:latin typeface="Courier New"/>
+              </a:rPr>
+              <a:t/>
+            </a:r>
+          </a:p>
+          <a:p>
+            <a:pPr algn="l">
+              <a:lnSpc>
+                <a:spcPct val="118000"/>
+              </a:lnSpc>
+            </a:pPr>
+            <a:r>
+              <a:rPr sz="1380" b="0" i="0">
+                <a:solidFill>
+                  <a:srgbClr val="2B2C30"/>
+                </a:solidFill>
+                <a:latin typeface="Courier New"/>
+              </a:rPr>
+              <a:t>Each run directory is self-contained: experiment_config.json, inputs,</a:t>
+            </a:r>
+          </a:p>
+          <a:p>
+            <a:pPr algn="l">
+              <a:lnSpc>
+                <a:spcPct val="118000"/>
+              </a:lnSpc>
+            </a:pPr>
+            <a:r>
+              <a:rPr sz="1380" b="0" i="0">
+                <a:solidFill>
+                  <a:srgbClr val="2B2C30"/>
+                </a:solidFill>
+                <a:latin typeface="Courier New"/>
+              </a:rPr>
+              <a:t>the rendered prompt, raw parse, normalized output, validation report.</a:t>
             </a:r>
           </a:p>
         </p:txBody>
@@ -8988,7 +9032,7 @@
                 </a:solidFill>
                 <a:latin typeface="Public Sans"/>
               </a:rPr>
-              <a:t>WHAT THE NUMBERS SAY</a:t>
+              <a:t>THE HARD MEASUREMENT: IS IT THE SAME PROBLEM?</a:t>
             </a:r>
           </a:p>
         </p:txBody>
@@ -9056,23 +9100,23 @@
               </a:lnSpc>
             </a:pPr>
             <a:r>
-              <a:rPr sz="1191" b="0" i="0">
-                <a:solidFill>
-                  <a:srgbClr val="2B2C30"/>
-                </a:solidFill>
-                <a:latin typeface="Courier New"/>
-              </a:rPr>
-              <a:t>RQ1  grade concordance against the expert reference  (n = 84)</a:t>
-            </a:r>
-          </a:p>
-          <a:p>
-            <a:pPr algn="l">
-              <a:lnSpc>
-                <a:spcPct val="118000"/>
-              </a:lnSpc>
-            </a:pPr>
-            <a:r>
-              <a:rPr sz="1191" b="0" i="0">
+              <a:rPr sz="1456" b="0" i="0">
+                <a:solidFill>
+                  <a:srgbClr val="2B2C30"/>
+                </a:solidFill>
+                <a:latin typeface="Courier New"/>
+              </a:rPr>
+              <a:t>String equality fails. Taxonomy overlap is too generous.</a:t>
+            </a:r>
+          </a:p>
+          <a:p>
+            <a:pPr algn="l">
+              <a:lnSpc>
+                <a:spcPct val="118000"/>
+              </a:lnSpc>
+            </a:pPr>
+            <a:r>
+              <a:rPr sz="1456" b="0" i="0">
                 <a:solidFill>
                   <a:srgbClr val="2B2C30"/>
                 </a:solidFill>
@@ -9088,119 +9132,215 @@
               </a:lnSpc>
             </a:pPr>
             <a:r>
-              <a:rPr sz="1191" b="0" i="0">
-                <a:solidFill>
-                  <a:srgbClr val="2B2C30"/>
-                </a:solidFill>
-                <a:latin typeface="Courier New"/>
-              </a:rPr>
-              <a:t>  +-------------------+-------+-------+-------+----------+</a:t>
-            </a:r>
-          </a:p>
-          <a:p>
-            <a:pPr algn="l">
-              <a:lnSpc>
-                <a:spcPct val="118000"/>
-              </a:lnSpc>
-            </a:pPr>
-            <a:r>
-              <a:rPr sz="1191" b="0" i="0">
-                <a:solidFill>
-                  <a:srgbClr val="2B2C30"/>
-                </a:solidFill>
-                <a:latin typeface="Courier New"/>
-              </a:rPr>
-              <a:t>  | evaluator         | mean  | MAE   | bias  | +/- 1 pt |</a:t>
-            </a:r>
-          </a:p>
-          <a:p>
-            <a:pPr algn="l">
-              <a:lnSpc>
-                <a:spcPct val="118000"/>
-              </a:lnSpc>
-            </a:pPr>
-            <a:r>
-              <a:rPr sz="1191" b="0" i="0">
-                <a:solidFill>
-                  <a:srgbClr val="2B2C30"/>
-                </a:solidFill>
-                <a:latin typeface="Courier New"/>
-              </a:rPr>
-              <a:t>  +-------------------+-------+-------+-------+----------+</a:t>
-            </a:r>
-          </a:p>
-          <a:p>
-            <a:pPr algn="l">
-              <a:lnSpc>
-                <a:spcPct val="118000"/>
-              </a:lnSpc>
-            </a:pPr>
-            <a:r>
-              <a:rPr sz="1191" b="0" i="0">
-                <a:solidFill>
-                  <a:srgbClr val="2B2C30"/>
-                </a:solidFill>
-                <a:latin typeface="Courier New"/>
-              </a:rPr>
-              <a:t>  | TA (baseline)     | 8.85  | 0.45  | +0.13 |   91.7%  |</a:t>
-            </a:r>
-          </a:p>
-          <a:p>
-            <a:pPr algn="l">
-              <a:lnSpc>
-                <a:spcPct val="118000"/>
-              </a:lnSpc>
-            </a:pPr>
-            <a:r>
-              <a:rPr sz="1191" b="0" i="0">
-                <a:solidFill>
-                  <a:srgbClr val="2B2C30"/>
-                </a:solidFill>
-                <a:latin typeface="Courier New"/>
-              </a:rPr>
-              <a:t>  | Gemini 3.1 Pro    | 8.85  | 0.44  | +0.14 |   92.5%  |</a:t>
-            </a:r>
-          </a:p>
-          <a:p>
-            <a:pPr algn="l">
-              <a:lnSpc>
-                <a:spcPct val="118000"/>
-              </a:lnSpc>
-            </a:pPr>
-            <a:r>
-              <a:rPr sz="1191" b="0" i="0">
-                <a:solidFill>
-                  <a:srgbClr val="2B2C30"/>
-                </a:solidFill>
-                <a:latin typeface="Courier New"/>
-              </a:rPr>
-              <a:t>  | GPT-5.5           | 7.26  | 1.48  | -1.45 |   27.4%  |</a:t>
-            </a:r>
-          </a:p>
-          <a:p>
-            <a:pPr algn="l">
-              <a:lnSpc>
-                <a:spcPct val="118000"/>
-              </a:lnSpc>
-            </a:pPr>
-            <a:r>
-              <a:rPr sz="1191" b="0" i="0">
-                <a:solidFill>
-                  <a:srgbClr val="2B2C30"/>
-                </a:solidFill>
-                <a:latin typeface="Courier New"/>
-              </a:rPr>
-              <a:t>  +-------------------+-------+-------+-------+----------+</a:t>
-            </a:r>
-          </a:p>
-          <a:p>
-            <a:pPr algn="l">
-              <a:lnSpc>
-                <a:spcPct val="118000"/>
-              </a:lnSpc>
-            </a:pPr>
-            <a:r>
-              <a:rPr sz="1191" b="0" i="0">
+              <a:rPr sz="1456" b="0" i="0">
+                <a:solidFill>
+                  <a:srgbClr val="2B2C30"/>
+                </a:solidFill>
+                <a:latin typeface="Courier New"/>
+              </a:rPr>
+              <a:t>  expert  (S17, class_modeling)     model  (S17, class_modeling)</a:t>
+            </a:r>
+          </a:p>
+          <a:p>
+            <a:pPr algn="l">
+              <a:lnSpc>
+                <a:spcPct val="118000"/>
+              </a:lnSpc>
+            </a:pPr>
+            <a:r>
+              <a:rPr sz="1456" b="0" i="0">
+                <a:solidFill>
+                  <a:srgbClr val="2B2C30"/>
+                </a:solidFill>
+                <a:latin typeface="Courier New"/>
+              </a:rPr>
+              <a:t>  "Filme has no encapsulation,      "attributes of Filme are public,</a:t>
+            </a:r>
+          </a:p>
+          <a:p>
+            <a:pPr algn="l">
+              <a:lnSpc>
+                <a:spcPct val="118000"/>
+              </a:lnSpc>
+            </a:pPr>
+            <a:r>
+              <a:rPr sz="1456" b="0" i="0">
+                <a:solidFill>
+                  <a:srgbClr val="2B2C30"/>
+                </a:solidFill>
+                <a:latin typeface="Courier New"/>
+              </a:rPr>
+              <a:t>   attributes are public"            information hiding is broken"</a:t>
+            </a:r>
+          </a:p>
+          <a:p>
+            <a:pPr algn="l">
+              <a:lnSpc>
+                <a:spcPct val="118000"/>
+              </a:lnSpc>
+            </a:pPr>
+            <a:r>
+              <a:rPr sz="1456" b="0" i="0">
+                <a:solidFill>
+                  <a:srgbClr val="2B2C30"/>
+                </a:solidFill>
+                <a:latin typeface="Courier New"/>
+              </a:rPr>
+              <a:t>                    \                    /</a:t>
+            </a:r>
+          </a:p>
+          <a:p>
+            <a:pPr algn="l">
+              <a:lnSpc>
+                <a:spcPct val="118000"/>
+              </a:lnSpc>
+            </a:pPr>
+            <a:r>
+              <a:rPr sz="1456" b="0" i="0">
+                <a:solidFill>
+                  <a:srgbClr val="2B2C30"/>
+                </a:solidFill>
+                <a:latin typeface="Courier New"/>
+              </a:rPr>
+              <a:t>                     v                  v</a:t>
+            </a:r>
+          </a:p>
+          <a:p>
+            <a:pPr algn="l">
+              <a:lnSpc>
+                <a:spcPct val="118000"/>
+              </a:lnSpc>
+            </a:pPr>
+            <a:r>
+              <a:rPr sz="1456" b="0" i="0">
+                <a:solidFill>
+                  <a:srgbClr val="2B2C30"/>
+                </a:solidFill>
+                <a:latin typeface="Courier New"/>
+              </a:rPr>
+              <a:t>        +-----------------------------------------+</a:t>
+            </a:r>
+          </a:p>
+          <a:p>
+            <a:pPr algn="l">
+              <a:lnSpc>
+                <a:spcPct val="118000"/>
+              </a:lnSpc>
+            </a:pPr>
+            <a:r>
+              <a:rPr sz="1456" b="0" i="0">
+                <a:solidFill>
+                  <a:srgbClr val="2B2C30"/>
+                </a:solidFill>
+                <a:latin typeface="Courier New"/>
+              </a:rPr>
+              <a:t>        |  adjudicator: Claude Sonnet 5           |  a third</a:t>
+            </a:r>
+          </a:p>
+          <a:p>
+            <a:pPr algn="l">
+              <a:lnSpc>
+                <a:spcPct val="118000"/>
+              </a:lnSpc>
+            </a:pPr>
+            <a:r>
+              <a:rPr sz="1456" b="0" i="0">
+                <a:solidFill>
+                  <a:srgbClr val="2B2C30"/>
+                </a:solidFill>
+                <a:latin typeface="Courier New"/>
+              </a:rPr>
+              <a:t>        |  temperature 0, structured JSON out     |  provider</a:t>
+            </a:r>
+          </a:p>
+          <a:p>
+            <a:pPr algn="l">
+              <a:lnSpc>
+                <a:spcPct val="118000"/>
+              </a:lnSpc>
+            </a:pPr>
+            <a:r>
+              <a:rPr sz="1456" b="0" i="0">
+                <a:solidFill>
+                  <a:srgbClr val="2B2C30"/>
+                </a:solidFill>
+                <a:latin typeface="Courier New"/>
+              </a:rPr>
+              <a:t>        |  scoped to submission_id | criterion    |  family, so</a:t>
+            </a:r>
+          </a:p>
+          <a:p>
+            <a:pPr algn="l">
+              <a:lnSpc>
+                <a:spcPct val="118000"/>
+              </a:lnSpc>
+            </a:pPr>
+            <a:r>
+              <a:rPr sz="1456" b="0" i="0">
+                <a:solidFill>
+                  <a:srgbClr val="2B2C30"/>
+                </a:solidFill>
+                <a:latin typeface="Courier New"/>
+              </a:rPr>
+              <a:t>        |  subsumption + many-to-many allowed     |  no home-</a:t>
+            </a:r>
+          </a:p>
+          <a:p>
+            <a:pPr algn="l">
+              <a:lnSpc>
+                <a:spcPct val="118000"/>
+              </a:lnSpc>
+            </a:pPr>
+            <a:r>
+              <a:rPr sz="1456" b="0" i="0">
+                <a:solidFill>
+                  <a:srgbClr val="2B2C30"/>
+                </a:solidFill>
+                <a:latin typeface="Courier New"/>
+              </a:rPr>
+              <a:t>        +-----------------------------------------+  team bias</a:t>
+            </a:r>
+          </a:p>
+          <a:p>
+            <a:pPr algn="l">
+              <a:lnSpc>
+                <a:spcPct val="118000"/>
+              </a:lnSpc>
+            </a:pPr>
+            <a:r>
+              <a:rPr sz="1456" b="0" i="0">
+                <a:solidFill>
+                  <a:srgbClr val="2B2C30"/>
+                </a:solidFill>
+                <a:latin typeface="Courier New"/>
+              </a:rPr>
+              <a:t>                            |</a:t>
+            </a:r>
+          </a:p>
+          <a:p>
+            <a:pPr algn="l">
+              <a:lnSpc>
+                <a:spcPct val="118000"/>
+              </a:lnSpc>
+            </a:pPr>
+            <a:r>
+              <a:rPr sz="1456" b="0" i="0">
+                <a:solidFill>
+                  <a:srgbClr val="2B2C30"/>
+                </a:solidFill>
+                <a:latin typeface="Courier New"/>
+              </a:rPr>
+              <a:t>    covered_expert = TP   uncovered_expert = FN   unmatched_llm = FP</a:t>
+            </a:r>
+          </a:p>
+          <a:p>
+            <a:pPr algn="l">
+              <a:lnSpc>
+                <a:spcPct val="118000"/>
+              </a:lnSpc>
+            </a:pPr>
+            <a:r>
+              <a:rPr sz="1456" b="0" i="0">
                 <a:solidFill>
                   <a:srgbClr val="2B2C30"/>
                 </a:solidFill>
@@ -9216,189 +9356,29 @@
               </a:lnSpc>
             </a:pPr>
             <a:r>
-              <a:rPr sz="1191" b="0" i="0">
-                <a:solidFill>
-                  <a:srgbClr val="2B2C30"/>
-                </a:solidFill>
-                <a:latin typeface="Courier New"/>
-              </a:rPr>
-              <a:t>RQ2  diagnostic alignment - same F1, opposite failure modes</a:t>
-            </a:r>
-          </a:p>
-          <a:p>
-            <a:pPr algn="l">
-              <a:lnSpc>
-                <a:spcPct val="118000"/>
-              </a:lnSpc>
-            </a:pPr>
-            <a:r>
-              <a:rPr sz="1191" b="0" i="0">
-                <a:solidFill>
-                  <a:srgbClr val="2B2C30"/>
-                </a:solidFill>
-                <a:latin typeface="Courier New"/>
-              </a:rPr>
-              <a:t/>
-            </a:r>
-          </a:p>
-          <a:p>
-            <a:pPr algn="l">
-              <a:lnSpc>
-                <a:spcPct val="118000"/>
-              </a:lnSpc>
-            </a:pPr>
-            <a:r>
-              <a:rPr sz="1191" b="0" i="0">
-                <a:solidFill>
-                  <a:srgbClr val="2B2C30"/>
-                </a:solidFill>
-                <a:latin typeface="Courier New"/>
-              </a:rPr>
-              <a:t>  +-------------------+-------+-------+-------+</a:t>
-            </a:r>
-          </a:p>
-          <a:p>
-            <a:pPr algn="l">
-              <a:lnSpc>
-                <a:spcPct val="118000"/>
-              </a:lnSpc>
-            </a:pPr>
-            <a:r>
-              <a:rPr sz="1191" b="0" i="0">
-                <a:solidFill>
-                  <a:srgbClr val="2B2C30"/>
-                </a:solidFill>
-                <a:latin typeface="Courier New"/>
-              </a:rPr>
-              <a:t>  | model             |  P    |  R    |  F1   |</a:t>
-            </a:r>
-          </a:p>
-          <a:p>
-            <a:pPr algn="l">
-              <a:lnSpc>
-                <a:spcPct val="118000"/>
-              </a:lnSpc>
-            </a:pPr>
-            <a:r>
-              <a:rPr sz="1191" b="0" i="0">
-                <a:solidFill>
-                  <a:srgbClr val="2B2C30"/>
-                </a:solidFill>
-                <a:latin typeface="Courier New"/>
-              </a:rPr>
-              <a:t>  +-------------------+-------+-------+-------+</a:t>
-            </a:r>
-          </a:p>
-          <a:p>
-            <a:pPr algn="l">
-              <a:lnSpc>
-                <a:spcPct val="118000"/>
-              </a:lnSpc>
-            </a:pPr>
-            <a:r>
-              <a:rPr sz="1191" b="0" i="0">
-                <a:solidFill>
-                  <a:srgbClr val="2B2C30"/>
-                </a:solidFill>
-                <a:latin typeface="Courier New"/>
-              </a:rPr>
-              <a:t>  | GPT-5.5           | 0.52  | 0.96  | 0.67  |   exhaustive, noisy</a:t>
-            </a:r>
-          </a:p>
-          <a:p>
-            <a:pPr algn="l">
-              <a:lnSpc>
-                <a:spcPct val="118000"/>
-              </a:lnSpc>
-            </a:pPr>
-            <a:r>
-              <a:rPr sz="1191" b="0" i="0">
-                <a:solidFill>
-                  <a:srgbClr val="2B2C30"/>
-                </a:solidFill>
-                <a:latin typeface="Courier New"/>
-              </a:rPr>
-              <a:t>  | Gemini 3.1 Pro    | 0.69  | 0.62  | 0.65  |   clean, incomplete</a:t>
-            </a:r>
-          </a:p>
-          <a:p>
-            <a:pPr algn="l">
-              <a:lnSpc>
-                <a:spcPct val="118000"/>
-              </a:lnSpc>
-            </a:pPr>
-            <a:r>
-              <a:rPr sz="1191" b="0" i="0">
-                <a:solidFill>
-                  <a:srgbClr val="2B2C30"/>
-                </a:solidFill>
-                <a:latin typeface="Courier New"/>
-              </a:rPr>
-              <a:t>  +-------------------+-------+-------+-------+</a:t>
-            </a:r>
-          </a:p>
-          <a:p>
-            <a:pPr algn="l">
-              <a:lnSpc>
-                <a:spcPct val="118000"/>
-              </a:lnSpc>
-            </a:pPr>
-            <a:r>
-              <a:rPr sz="1191" b="0" i="0">
-                <a:solidFill>
-                  <a:srgbClr val="2B2C30"/>
-                </a:solidFill>
-                <a:latin typeface="Courier New"/>
-              </a:rPr>
-              <a:t/>
-            </a:r>
-          </a:p>
-          <a:p>
-            <a:pPr algn="l">
-              <a:lnSpc>
-                <a:spcPct val="118000"/>
-              </a:lnSpc>
-            </a:pPr>
-            <a:r>
-              <a:rPr sz="1191" b="0" i="0">
-                <a:solidFill>
-                  <a:srgbClr val="2B2C30"/>
-                </a:solidFill>
-                <a:latin typeface="Courier New"/>
-              </a:rPr>
-              <a:t>Stability: ICC 0.89 / 0.90, yet exact 3-run agreement 2.4% / 0.0%</a:t>
-            </a:r>
-          </a:p>
-          <a:p>
-            <a:pPr algn="l">
-              <a:lnSpc>
-                <a:spcPct val="118000"/>
-              </a:lnSpc>
-            </a:pPr>
-            <a:r>
-              <a:rPr sz="1191" b="0" i="0">
-                <a:solidFill>
-                  <a:srgbClr val="2B2C30"/>
-                </a:solidFill>
-                <a:latin typeface="Courier New"/>
-              </a:rPr>
-              <a:t/>
-            </a:r>
-          </a:p>
-          <a:p>
-            <a:pPr algn="l">
-              <a:lnSpc>
-                <a:spcPct val="118000"/>
-              </a:lnSpc>
-            </a:pPr>
-            <a:r>
-              <a:rPr sz="1191" b="0" i="0">
-                <a:solidFill>
-                  <a:srgbClr val="2B2C30"/>
-                </a:solidFill>
-                <a:latin typeface="Courier New"/>
-              </a:rPr>
-              <a:t>Grading is easy. Feedback is hard.</a:t>
+              <a:rPr sz="1456" b="0" i="0">
+                <a:solidFill>
+                  <a:srgbClr val="2B2C30"/>
+                </a:solidFill>
+                <a:latin typeface="Courier New"/>
+              </a:rPr>
+              <a:t>The prompt, the model id and every cache entry ship in the artifact.</a:t>
+            </a:r>
+          </a:p>
+          <a:p>
+            <a:pPr algn="l">
+              <a:lnSpc>
+                <a:spcPct val="118000"/>
+              </a:lnSpc>
+            </a:pPr>
+            <a:r>
+              <a:rPr sz="1456" b="0" i="0">
+                <a:solidFill>
+                  <a:srgbClr val="2B2C30"/>
+                </a:solidFill>
+                <a:latin typeface="Courier New"/>
+              </a:rPr>
+              <a:t>Sensitivity check: reversing 10 decisions shifts P/R by under 0.04.</a:t>
             </a:r>
           </a:p>
         </p:txBody>

</xml_diff>